<commit_message>
docs: add VANET literature survey section
Co-authored-by: zhang10225 <96326423+zhang10225@users.noreply.github.com>
</commit_message>
<xml_diff>
--- a/docs/VANET-弱硬件实时撤销与事后追责调研.pptx
+++ b/docs/VANET-弱硬件实时撤销与事后追责调研.pptx
@@ -18,6 +18,7 @@
     <p:sldId id="266" r:id="rId17"/>
     <p:sldId id="267" r:id="rId18"/>
     <p:sldId id="268" r:id="rId19"/>
+    <p:sldId id="269" r:id="rId20"/>
   </p:sldIdLst>
   <p:sldSz cx="12191695" cy="6858000" type="screen4x3"/>
   <p:notesSz cx="6858000" cy="9144000"/>
@@ -3502,7 +3503,7 @@
         <p:spPr>
           <a:xfrm>
             <a:off x="502920" y="109728"/>
-            <a:ext cx="10789920" cy="365760"/>
+            <a:ext cx="10972800" cy="365760"/>
           </a:xfrm>
           <a:prstGeom prst="rect">
             <a:avLst/>
@@ -3536,7 +3537,7 @@
         <p:spPr>
           <a:xfrm>
             <a:off x="685800" y="1234440"/>
-            <a:ext cx="10972800" cy="4754880"/>
+            <a:ext cx="10972800" cy="4846320"/>
           </a:xfrm>
           <a:prstGeom prst="rect">
             <a:avLst/>
@@ -3551,10 +3552,10 @@
           <a:p>
             <a:pPr>
               <a:spcBef>
-                <a:spcPts val="200"/>
-              </a:spcBef>
-              <a:spcAft>
-                <a:spcPts val="500"/>
+                <a:spcPts val="100"/>
+              </a:spcBef>
+              <a:spcAft>
+                <a:spcPts val="400"/>
               </a:spcAft>
             </a:pPr>
             <a:r>
@@ -3570,10 +3571,10 @@
           <a:p>
             <a:pPr>
               <a:spcBef>
-                <a:spcPts val="200"/>
-              </a:spcBef>
-              <a:spcAft>
-                <a:spcPts val="500"/>
+                <a:spcPts val="100"/>
+              </a:spcBef>
+              <a:spcAft>
+                <a:spcPts val="400"/>
               </a:spcAft>
             </a:pPr>
             <a:r>
@@ -3589,10 +3590,10 @@
           <a:p>
             <a:pPr>
               <a:spcBef>
-                <a:spcPts val="200"/>
-              </a:spcBef>
-              <a:spcAft>
-                <a:spcPts val="500"/>
+                <a:spcPts val="100"/>
+              </a:spcBef>
+              <a:spcAft>
+                <a:spcPts val="400"/>
               </a:spcAft>
             </a:pPr>
             <a:r>
@@ -3608,10 +3609,10 @@
           <a:p>
             <a:pPr>
               <a:spcBef>
-                <a:spcPts val="200"/>
-              </a:spcBef>
-              <a:spcAft>
-                <a:spcPts val="500"/>
+                <a:spcPts val="100"/>
+              </a:spcBef>
+              <a:spcAft>
+                <a:spcPts val="400"/>
               </a:spcAft>
             </a:pPr>
             <a:r>
@@ -3627,10 +3628,10 @@
           <a:p>
             <a:pPr>
               <a:spcBef>
-                <a:spcPts val="200"/>
-              </a:spcBef>
-              <a:spcAft>
-                <a:spcPts val="500"/>
+                <a:spcPts val="100"/>
+              </a:spcBef>
+              <a:spcAft>
+                <a:spcPts val="400"/>
               </a:spcAft>
             </a:pPr>
             <a:r>
@@ -3646,10 +3647,10 @@
           <a:p>
             <a:pPr>
               <a:spcBef>
-                <a:spcPts val="200"/>
-              </a:spcBef>
-              <a:spcAft>
-                <a:spcPts val="500"/>
+                <a:spcPts val="100"/>
+              </a:spcBef>
+              <a:spcAft>
+                <a:spcPts val="400"/>
               </a:spcAft>
             </a:pPr>
             <a:r>
@@ -3665,10 +3666,10 @@
           <a:p>
             <a:pPr>
               <a:spcBef>
-                <a:spcPts val="200"/>
-              </a:spcBef>
-              <a:spcAft>
-                <a:spcPts val="500"/>
+                <a:spcPts val="100"/>
+              </a:spcBef>
+              <a:spcAft>
+                <a:spcPts val="400"/>
               </a:spcAft>
             </a:pPr>
             <a:r>
@@ -3684,10 +3685,10 @@
           <a:p>
             <a:pPr>
               <a:spcBef>
-                <a:spcPts val="200"/>
-              </a:spcBef>
-              <a:spcAft>
-                <a:spcPts val="500"/>
+                <a:spcPts val="100"/>
+              </a:spcBef>
+              <a:spcAft>
+                <a:spcPts val="400"/>
               </a:spcAft>
             </a:pPr>
             <a:r>
@@ -3703,10 +3704,10 @@
           <a:p>
             <a:pPr>
               <a:spcBef>
-                <a:spcPts val="200"/>
-              </a:spcBef>
-              <a:spcAft>
-                <a:spcPts val="500"/>
+                <a:spcPts val="100"/>
+              </a:spcBef>
+              <a:spcAft>
+                <a:spcPts val="400"/>
               </a:spcAft>
             </a:pPr>
             <a:r>
@@ -3722,10 +3723,10 @@
           <a:p>
             <a:pPr>
               <a:spcBef>
-                <a:spcPts val="200"/>
-              </a:spcBef>
-              <a:spcAft>
-                <a:spcPts val="500"/>
+                <a:spcPts val="100"/>
+              </a:spcBef>
+              <a:spcAft>
+                <a:spcPts val="400"/>
               </a:spcAft>
             </a:pPr>
             <a:r>
@@ -3741,10 +3742,10 @@
           <a:p>
             <a:pPr>
               <a:spcBef>
-                <a:spcPts val="200"/>
-              </a:spcBef>
-              <a:spcAft>
-                <a:spcPts val="500"/>
+                <a:spcPts val="100"/>
+              </a:spcBef>
+              <a:spcAft>
+                <a:spcPts val="400"/>
               </a:spcAft>
             </a:pPr>
             <a:r>
@@ -3760,10 +3761,10 @@
           <a:p>
             <a:pPr>
               <a:spcBef>
-                <a:spcPts val="200"/>
-              </a:spcBef>
-              <a:spcAft>
-                <a:spcPts val="500"/>
+                <a:spcPts val="100"/>
+              </a:spcBef>
+              <a:spcAft>
+                <a:spcPts val="400"/>
               </a:spcAft>
             </a:pPr>
             <a:r>
@@ -3786,8 +3787,8 @@
         </p:nvSpPr>
         <p:spPr>
           <a:xfrm>
-            <a:off x="594360" y="6263640"/>
-            <a:ext cx="10972800" cy="274320"/>
+            <a:off x="594360" y="6236208"/>
+            <a:ext cx="10972800" cy="228600"/>
           </a:xfrm>
           <a:prstGeom prst="rect">
             <a:avLst/>
@@ -3927,7 +3928,7 @@
         <p:spPr>
           <a:xfrm>
             <a:off x="502920" y="109728"/>
-            <a:ext cx="10789920" cy="365760"/>
+            <a:ext cx="10972800" cy="365760"/>
           </a:xfrm>
           <a:prstGeom prst="rect">
             <a:avLst/>
@@ -3961,7 +3962,7 @@
         <p:spPr>
           <a:xfrm>
             <a:off x="685800" y="1234440"/>
-            <a:ext cx="10972800" cy="4754880"/>
+            <a:ext cx="10972800" cy="4846320"/>
           </a:xfrm>
           <a:prstGeom prst="rect">
             <a:avLst/>
@@ -3976,14 +3977,14 @@
           <a:p>
             <a:pPr>
               <a:spcBef>
-                <a:spcPts val="200"/>
-              </a:spcBef>
-              <a:spcAft>
-                <a:spcPts val="500"/>
-              </a:spcAft>
-            </a:pPr>
-            <a:r>
-              <a:rPr sz="1800">
+                <a:spcPts val="100"/>
+              </a:spcBef>
+              <a:spcAft>
+                <a:spcPts val="400"/>
+              </a:spcAft>
+            </a:pPr>
+            <a:r>
+              <a:rPr sz="1600">
                 <a:solidFill>
                   <a:srgbClr val="0F172A"/>
                 </a:solidFill>
@@ -3995,14 +3996,14 @@
           <a:p>
             <a:pPr>
               <a:spcBef>
-                <a:spcPts val="200"/>
-              </a:spcBef>
-              <a:spcAft>
-                <a:spcPts val="500"/>
-              </a:spcAft>
-            </a:pPr>
-            <a:r>
-              <a:rPr sz="1800">
+                <a:spcPts val="100"/>
+              </a:spcBef>
+              <a:spcAft>
+                <a:spcPts val="400"/>
+              </a:spcAft>
+            </a:pPr>
+            <a:r>
+              <a:rPr sz="1600">
                 <a:solidFill>
                   <a:srgbClr val="0F172A"/>
                 </a:solidFill>
@@ -4014,14 +4015,14 @@
           <a:p>
             <a:pPr>
               <a:spcBef>
-                <a:spcPts val="200"/>
-              </a:spcBef>
-              <a:spcAft>
-                <a:spcPts val="500"/>
-              </a:spcAft>
-            </a:pPr>
-            <a:r>
-              <a:rPr sz="1800">
+                <a:spcPts val="100"/>
+              </a:spcBef>
+              <a:spcAft>
+                <a:spcPts val="400"/>
+              </a:spcAft>
+            </a:pPr>
+            <a:r>
+              <a:rPr sz="1600">
                 <a:solidFill>
                   <a:srgbClr val="0F172A"/>
                 </a:solidFill>
@@ -4033,14 +4034,14 @@
           <a:p>
             <a:pPr>
               <a:spcBef>
-                <a:spcPts val="200"/>
-              </a:spcBef>
-              <a:spcAft>
-                <a:spcPts val="500"/>
-              </a:spcAft>
-            </a:pPr>
-            <a:r>
-              <a:rPr sz="1800">
+                <a:spcPts val="100"/>
+              </a:spcBef>
+              <a:spcAft>
+                <a:spcPts val="400"/>
+              </a:spcAft>
+            </a:pPr>
+            <a:r>
+              <a:rPr sz="1600">
                 <a:solidFill>
                   <a:srgbClr val="0F172A"/>
                 </a:solidFill>
@@ -4052,14 +4053,14 @@
           <a:p>
             <a:pPr>
               <a:spcBef>
-                <a:spcPts val="200"/>
-              </a:spcBef>
-              <a:spcAft>
-                <a:spcPts val="500"/>
-              </a:spcAft>
-            </a:pPr>
-            <a:r>
-              <a:rPr sz="1800">
+                <a:spcPts val="100"/>
+              </a:spcBef>
+              <a:spcAft>
+                <a:spcPts val="400"/>
+              </a:spcAft>
+            </a:pPr>
+            <a:r>
+              <a:rPr sz="1600">
                 <a:solidFill>
                   <a:srgbClr val="0F172A"/>
                 </a:solidFill>
@@ -4071,14 +4072,14 @@
           <a:p>
             <a:pPr>
               <a:spcBef>
-                <a:spcPts val="200"/>
-              </a:spcBef>
-              <a:spcAft>
-                <a:spcPts val="500"/>
-              </a:spcAft>
-            </a:pPr>
-            <a:r>
-              <a:rPr sz="1800">
+                <a:spcPts val="100"/>
+              </a:spcBef>
+              <a:spcAft>
+                <a:spcPts val="400"/>
+              </a:spcAft>
+            </a:pPr>
+            <a:r>
+              <a:rPr sz="1600">
                 <a:solidFill>
                   <a:srgbClr val="0F172A"/>
                 </a:solidFill>
@@ -4090,14 +4091,14 @@
           <a:p>
             <a:pPr>
               <a:spcBef>
-                <a:spcPts val="200"/>
-              </a:spcBef>
-              <a:spcAft>
-                <a:spcPts val="500"/>
-              </a:spcAft>
-            </a:pPr>
-            <a:r>
-              <a:rPr sz="1800">
+                <a:spcPts val="100"/>
+              </a:spcBef>
+              <a:spcAft>
+                <a:spcPts val="400"/>
+              </a:spcAft>
+            </a:pPr>
+            <a:r>
+              <a:rPr sz="1600">
                 <a:solidFill>
                   <a:srgbClr val="0F172A"/>
                 </a:solidFill>
@@ -4109,14 +4110,14 @@
           <a:p>
             <a:pPr>
               <a:spcBef>
-                <a:spcPts val="200"/>
-              </a:spcBef>
-              <a:spcAft>
-                <a:spcPts val="500"/>
-              </a:spcAft>
-            </a:pPr>
-            <a:r>
-              <a:rPr sz="1800">
+                <a:spcPts val="100"/>
+              </a:spcBef>
+              <a:spcAft>
+                <a:spcPts val="400"/>
+              </a:spcAft>
+            </a:pPr>
+            <a:r>
+              <a:rPr sz="1600">
                 <a:solidFill>
                   <a:srgbClr val="0F172A"/>
                 </a:solidFill>
@@ -4128,14 +4129,14 @@
           <a:p>
             <a:pPr>
               <a:spcBef>
-                <a:spcPts val="200"/>
-              </a:spcBef>
-              <a:spcAft>
-                <a:spcPts val="500"/>
-              </a:spcAft>
-            </a:pPr>
-            <a:r>
-              <a:rPr sz="1800">
+                <a:spcPts val="100"/>
+              </a:spcBef>
+              <a:spcAft>
+                <a:spcPts val="400"/>
+              </a:spcAft>
+            </a:pPr>
+            <a:r>
+              <a:rPr sz="1600">
                 <a:solidFill>
                   <a:srgbClr val="0F172A"/>
                 </a:solidFill>
@@ -4147,14 +4148,14 @@
           <a:p>
             <a:pPr>
               <a:spcBef>
-                <a:spcPts val="200"/>
-              </a:spcBef>
-              <a:spcAft>
-                <a:spcPts val="500"/>
-              </a:spcAft>
-            </a:pPr>
-            <a:r>
-              <a:rPr sz="1800">
+                <a:spcPts val="100"/>
+              </a:spcBef>
+              <a:spcAft>
+                <a:spcPts val="400"/>
+              </a:spcAft>
+            </a:pPr>
+            <a:r>
+              <a:rPr sz="1600">
                 <a:solidFill>
                   <a:srgbClr val="0F172A"/>
                 </a:solidFill>
@@ -4166,14 +4167,14 @@
           <a:p>
             <a:pPr>
               <a:spcBef>
-                <a:spcPts val="200"/>
-              </a:spcBef>
-              <a:spcAft>
-                <a:spcPts val="500"/>
-              </a:spcAft>
-            </a:pPr>
-            <a:r>
-              <a:rPr sz="1800">
+                <a:spcPts val="100"/>
+              </a:spcBef>
+              <a:spcAft>
+                <a:spcPts val="400"/>
+              </a:spcAft>
+            </a:pPr>
+            <a:r>
+              <a:rPr sz="1600">
                 <a:solidFill>
                   <a:srgbClr val="0F172A"/>
                 </a:solidFill>
@@ -4185,14 +4186,14 @@
           <a:p>
             <a:pPr>
               <a:spcBef>
-                <a:spcPts val="200"/>
-              </a:spcBef>
-              <a:spcAft>
-                <a:spcPts val="500"/>
-              </a:spcAft>
-            </a:pPr>
-            <a:r>
-              <a:rPr sz="1800">
+                <a:spcPts val="100"/>
+              </a:spcBef>
+              <a:spcAft>
+                <a:spcPts val="400"/>
+              </a:spcAft>
+            </a:pPr>
+            <a:r>
+              <a:rPr sz="1600">
                 <a:solidFill>
                   <a:srgbClr val="0F172A"/>
                 </a:solidFill>
@@ -4204,14 +4205,14 @@
           <a:p>
             <a:pPr>
               <a:spcBef>
-                <a:spcPts val="200"/>
-              </a:spcBef>
-              <a:spcAft>
-                <a:spcPts val="500"/>
-              </a:spcAft>
-            </a:pPr>
-            <a:r>
-              <a:rPr sz="1800">
+                <a:spcPts val="100"/>
+              </a:spcBef>
+              <a:spcAft>
+                <a:spcPts val="400"/>
+              </a:spcAft>
+            </a:pPr>
+            <a:r>
+              <a:rPr sz="1600">
                 <a:solidFill>
                   <a:srgbClr val="0F172A"/>
                 </a:solidFill>
@@ -4223,14 +4224,14 @@
           <a:p>
             <a:pPr>
               <a:spcBef>
-                <a:spcPts val="200"/>
-              </a:spcBef>
-              <a:spcAft>
-                <a:spcPts val="500"/>
-              </a:spcAft>
-            </a:pPr>
-            <a:r>
-              <a:rPr sz="1800">
+                <a:spcPts val="100"/>
+              </a:spcBef>
+              <a:spcAft>
+                <a:spcPts val="400"/>
+              </a:spcAft>
+            </a:pPr>
+            <a:r>
+              <a:rPr sz="1600">
                 <a:solidFill>
                   <a:srgbClr val="0F172A"/>
                 </a:solidFill>
@@ -4242,14 +4243,14 @@
           <a:p>
             <a:pPr>
               <a:spcBef>
-                <a:spcPts val="200"/>
-              </a:spcBef>
-              <a:spcAft>
-                <a:spcPts val="500"/>
-              </a:spcAft>
-            </a:pPr>
-            <a:r>
-              <a:rPr sz="1800">
+                <a:spcPts val="100"/>
+              </a:spcBef>
+              <a:spcAft>
+                <a:spcPts val="400"/>
+              </a:spcAft>
+            </a:pPr>
+            <a:r>
+              <a:rPr sz="1600">
                 <a:solidFill>
                   <a:srgbClr val="0F172A"/>
                 </a:solidFill>
@@ -4261,14 +4262,14 @@
           <a:p>
             <a:pPr>
               <a:spcBef>
-                <a:spcPts val="200"/>
-              </a:spcBef>
-              <a:spcAft>
-                <a:spcPts val="500"/>
-              </a:spcAft>
-            </a:pPr>
-            <a:r>
-              <a:rPr sz="1800">
+                <a:spcPts val="100"/>
+              </a:spcBef>
+              <a:spcAft>
+                <a:spcPts val="400"/>
+              </a:spcAft>
+            </a:pPr>
+            <a:r>
+              <a:rPr sz="1600">
                 <a:solidFill>
                   <a:srgbClr val="0F172A"/>
                 </a:solidFill>
@@ -4287,8 +4288,8 @@
         </p:nvSpPr>
         <p:spPr>
           <a:xfrm>
-            <a:off x="594360" y="6263640"/>
-            <a:ext cx="10972800" cy="274320"/>
+            <a:off x="594360" y="6236208"/>
+            <a:ext cx="10972800" cy="228600"/>
           </a:xfrm>
           <a:prstGeom prst="rect">
             <a:avLst/>
@@ -4428,7 +4429,7 @@
         <p:spPr>
           <a:xfrm>
             <a:off x="502920" y="109728"/>
-            <a:ext cx="10789920" cy="365760"/>
+            <a:ext cx="10972800" cy="365760"/>
           </a:xfrm>
           <a:prstGeom prst="rect">
             <a:avLst/>
@@ -4462,7 +4463,7 @@
         <p:spPr>
           <a:xfrm>
             <a:off x="685800" y="1234440"/>
-            <a:ext cx="10972800" cy="4754880"/>
+            <a:ext cx="10972800" cy="4846320"/>
           </a:xfrm>
           <a:prstGeom prst="rect">
             <a:avLst/>
@@ -4477,10 +4478,10 @@
           <a:p>
             <a:pPr>
               <a:spcBef>
-                <a:spcPts val="200"/>
-              </a:spcBef>
-              <a:spcAft>
-                <a:spcPts val="500"/>
+                <a:spcPts val="100"/>
+              </a:spcBef>
+              <a:spcAft>
+                <a:spcPts val="400"/>
               </a:spcAft>
             </a:pPr>
             <a:r>
@@ -4496,10 +4497,10 @@
           <a:p>
             <a:pPr>
               <a:spcBef>
-                <a:spcPts val="200"/>
-              </a:spcBef>
-              <a:spcAft>
-                <a:spcPts val="500"/>
+                <a:spcPts val="100"/>
+              </a:spcBef>
+              <a:spcAft>
+                <a:spcPts val="400"/>
               </a:spcAft>
             </a:pPr>
             <a:r>
@@ -4515,10 +4516,10 @@
           <a:p>
             <a:pPr lvl="1">
               <a:spcBef>
-                <a:spcPts val="200"/>
-              </a:spcBef>
-              <a:spcAft>
-                <a:spcPts val="500"/>
+                <a:spcPts val="100"/>
+              </a:spcBef>
+              <a:spcAft>
+                <a:spcPts val="400"/>
               </a:spcAft>
             </a:pPr>
             <a:r>
@@ -4534,10 +4535,10 @@
           <a:p>
             <a:pPr>
               <a:spcBef>
-                <a:spcPts val="200"/>
-              </a:spcBef>
-              <a:spcAft>
-                <a:spcPts val="500"/>
+                <a:spcPts val="100"/>
+              </a:spcBef>
+              <a:spcAft>
+                <a:spcPts val="400"/>
               </a:spcAft>
             </a:pPr>
             <a:r>
@@ -4553,10 +4554,10 @@
           <a:p>
             <a:pPr lvl="1">
               <a:spcBef>
-                <a:spcPts val="200"/>
-              </a:spcBef>
-              <a:spcAft>
-                <a:spcPts val="500"/>
+                <a:spcPts val="100"/>
+              </a:spcBef>
+              <a:spcAft>
+                <a:spcPts val="400"/>
               </a:spcAft>
             </a:pPr>
             <a:r>
@@ -4572,10 +4573,10 @@
           <a:p>
             <a:pPr lvl="1">
               <a:spcBef>
-                <a:spcPts val="200"/>
-              </a:spcBef>
-              <a:spcAft>
-                <a:spcPts val="500"/>
+                <a:spcPts val="100"/>
+              </a:spcBef>
+              <a:spcAft>
+                <a:spcPts val="400"/>
               </a:spcAft>
             </a:pPr>
             <a:r>
@@ -4591,10 +4592,10 @@
           <a:p>
             <a:pPr lvl="1">
               <a:spcBef>
-                <a:spcPts val="200"/>
-              </a:spcBef>
-              <a:spcAft>
-                <a:spcPts val="500"/>
+                <a:spcPts val="100"/>
+              </a:spcBef>
+              <a:spcAft>
+                <a:spcPts val="400"/>
               </a:spcAft>
             </a:pPr>
             <a:r>
@@ -4610,10 +4611,10 @@
           <a:p>
             <a:pPr>
               <a:spcBef>
-                <a:spcPts val="200"/>
-              </a:spcBef>
-              <a:spcAft>
-                <a:spcPts val="500"/>
+                <a:spcPts val="100"/>
+              </a:spcBef>
+              <a:spcAft>
+                <a:spcPts val="400"/>
               </a:spcAft>
             </a:pPr>
             <a:r>
@@ -4629,10 +4630,10 @@
           <a:p>
             <a:pPr lvl="1">
               <a:spcBef>
-                <a:spcPts val="200"/>
-              </a:spcBef>
-              <a:spcAft>
-                <a:spcPts val="500"/>
+                <a:spcPts val="100"/>
+              </a:spcBef>
+              <a:spcAft>
+                <a:spcPts val="400"/>
               </a:spcAft>
             </a:pPr>
             <a:r>
@@ -4648,10 +4649,10 @@
           <a:p>
             <a:pPr lvl="1">
               <a:spcBef>
-                <a:spcPts val="200"/>
-              </a:spcBef>
-              <a:spcAft>
-                <a:spcPts val="500"/>
+                <a:spcPts val="100"/>
+              </a:spcBef>
+              <a:spcAft>
+                <a:spcPts val="400"/>
               </a:spcAft>
             </a:pPr>
             <a:r>
@@ -4780,7 +4781,7 @@
         <p:spPr>
           <a:xfrm>
             <a:off x="502920" y="109728"/>
-            <a:ext cx="10789920" cy="365760"/>
+            <a:ext cx="10972800" cy="365760"/>
           </a:xfrm>
           <a:prstGeom prst="rect">
             <a:avLst/>
@@ -4800,7 +4801,1874 @@
                 </a:solidFill>
                 <a:latin typeface="Microsoft YaHei"/>
               </a:rPr>
-              <a:t>12. 参考资料（可直接放到答辩/PPT 最后一页）</a:t>
+              <a:t>12. 联网补充：值得优先阅读的文献与资料</a:t>
+            </a:r>
+          </a:p>
+        </p:txBody>
+      </p:sp>
+      <p:sp>
+        <p:nvSpPr>
+          <p:cNvPr id="5" name="Rounded Rectangle 4"/>
+          <p:cNvSpPr/>
+          <p:nvPr/>
+        </p:nvSpPr>
+        <p:spPr>
+          <a:xfrm>
+            <a:off x="594360" y="1325880"/>
+            <a:ext cx="2331720" cy="576072"/>
+          </a:xfrm>
+          <a:prstGeom prst="roundRect">
+            <a:avLst/>
+          </a:prstGeom>
+          <a:solidFill>
+            <a:srgbClr val="2563EB"/>
+          </a:solidFill>
+          <a:ln>
+            <a:solidFill>
+              <a:srgbClr val="2563EB"/>
+            </a:solidFill>
+          </a:ln>
+        </p:spPr>
+        <p:style>
+          <a:lnRef idx="1">
+            <a:schemeClr val="accent1"/>
+          </a:lnRef>
+          <a:fillRef idx="3">
+            <a:schemeClr val="accent1"/>
+          </a:fillRef>
+          <a:effectRef idx="2">
+            <a:schemeClr val="accent1"/>
+          </a:effectRef>
+          <a:fontRef idx="minor">
+            <a:schemeClr val="lt1"/>
+          </a:fontRef>
+        </p:style>
+        <p:txBody>
+          <a:bodyPr rtlCol="0" anchor="ctr"/>
+          <a:lstStyle/>
+          <a:p>
+            <a:pPr algn="ctr"/>
+          </a:p>
+        </p:txBody>
+      </p:sp>
+      <p:sp>
+        <p:nvSpPr>
+          <p:cNvPr id="6" name="TextBox 5"/>
+          <p:cNvSpPr txBox="1"/>
+          <p:nvPr/>
+        </p:nvSpPr>
+        <p:spPr>
+          <a:xfrm>
+            <a:off x="667512" y="1399032"/>
+            <a:ext cx="2212848" cy="320040"/>
+          </a:xfrm>
+          <a:prstGeom prst="rect">
+            <a:avLst/>
+          </a:prstGeom>
+          <a:noFill/>
+        </p:spPr>
+        <p:txBody>
+          <a:bodyPr wrap="none">
+            <a:spAutoFit/>
+          </a:bodyPr>
+          <a:lstStyle/>
+          <a:p>
+            <a:r>
+              <a:rPr sz="1500" b="1">
+                <a:solidFill>
+                  <a:srgbClr val="FFFFFF"/>
+                </a:solidFill>
+                <a:latin typeface="Microsoft YaHei"/>
+              </a:rPr>
+              <a:t>方向</a:t>
+            </a:r>
+          </a:p>
+        </p:txBody>
+      </p:sp>
+      <p:sp>
+        <p:nvSpPr>
+          <p:cNvPr id="7" name="Rounded Rectangle 6"/>
+          <p:cNvSpPr/>
+          <p:nvPr/>
+        </p:nvSpPr>
+        <p:spPr>
+          <a:xfrm>
+            <a:off x="2971800" y="1325880"/>
+            <a:ext cx="1600200" cy="576072"/>
+          </a:xfrm>
+          <a:prstGeom prst="roundRect">
+            <a:avLst/>
+          </a:prstGeom>
+          <a:solidFill>
+            <a:srgbClr val="2563EB"/>
+          </a:solidFill>
+          <a:ln>
+            <a:solidFill>
+              <a:srgbClr val="2563EB"/>
+            </a:solidFill>
+          </a:ln>
+        </p:spPr>
+        <p:style>
+          <a:lnRef idx="1">
+            <a:schemeClr val="accent1"/>
+          </a:lnRef>
+          <a:fillRef idx="3">
+            <a:schemeClr val="accent1"/>
+          </a:fillRef>
+          <a:effectRef idx="2">
+            <a:schemeClr val="accent1"/>
+          </a:effectRef>
+          <a:fontRef idx="minor">
+            <a:schemeClr val="lt1"/>
+          </a:fontRef>
+        </p:style>
+        <p:txBody>
+          <a:bodyPr rtlCol="0" anchor="ctr"/>
+          <a:lstStyle/>
+          <a:p>
+            <a:pPr algn="ctr"/>
+          </a:p>
+        </p:txBody>
+      </p:sp>
+      <p:sp>
+        <p:nvSpPr>
+          <p:cNvPr id="8" name="TextBox 7"/>
+          <p:cNvSpPr txBox="1"/>
+          <p:nvPr/>
+        </p:nvSpPr>
+        <p:spPr>
+          <a:xfrm>
+            <a:off x="3044952" y="1399032"/>
+            <a:ext cx="1481328" cy="320040"/>
+          </a:xfrm>
+          <a:prstGeom prst="rect">
+            <a:avLst/>
+          </a:prstGeom>
+          <a:noFill/>
+        </p:spPr>
+        <p:txBody>
+          <a:bodyPr wrap="none">
+            <a:spAutoFit/>
+          </a:bodyPr>
+          <a:lstStyle/>
+          <a:p>
+            <a:r>
+              <a:rPr sz="1500" b="1">
+                <a:solidFill>
+                  <a:srgbClr val="FFFFFF"/>
+                </a:solidFill>
+                <a:latin typeface="Microsoft YaHei"/>
+              </a:rPr>
+              <a:t>现状判断</a:t>
+            </a:r>
+          </a:p>
+        </p:txBody>
+      </p:sp>
+      <p:sp>
+        <p:nvSpPr>
+          <p:cNvPr id="9" name="Rounded Rectangle 8"/>
+          <p:cNvSpPr/>
+          <p:nvPr/>
+        </p:nvSpPr>
+        <p:spPr>
+          <a:xfrm>
+            <a:off x="4617720" y="1325880"/>
+            <a:ext cx="6812280" cy="576072"/>
+          </a:xfrm>
+          <a:prstGeom prst="roundRect">
+            <a:avLst/>
+          </a:prstGeom>
+          <a:solidFill>
+            <a:srgbClr val="2563EB"/>
+          </a:solidFill>
+          <a:ln>
+            <a:solidFill>
+              <a:srgbClr val="2563EB"/>
+            </a:solidFill>
+          </a:ln>
+        </p:spPr>
+        <p:style>
+          <a:lnRef idx="1">
+            <a:schemeClr val="accent1"/>
+          </a:lnRef>
+          <a:fillRef idx="3">
+            <a:schemeClr val="accent1"/>
+          </a:fillRef>
+          <a:effectRef idx="2">
+            <a:schemeClr val="accent1"/>
+          </a:effectRef>
+          <a:fontRef idx="minor">
+            <a:schemeClr val="lt1"/>
+          </a:fontRef>
+        </p:style>
+        <p:txBody>
+          <a:bodyPr rtlCol="0" anchor="ctr"/>
+          <a:lstStyle/>
+          <a:p>
+            <a:pPr algn="ctr"/>
+          </a:p>
+        </p:txBody>
+      </p:sp>
+      <p:sp>
+        <p:nvSpPr>
+          <p:cNvPr id="10" name="TextBox 9"/>
+          <p:cNvSpPr txBox="1"/>
+          <p:nvPr/>
+        </p:nvSpPr>
+        <p:spPr>
+          <a:xfrm>
+            <a:off x="4690872" y="1399032"/>
+            <a:ext cx="6693408" cy="320040"/>
+          </a:xfrm>
+          <a:prstGeom prst="rect">
+            <a:avLst/>
+          </a:prstGeom>
+          <a:noFill/>
+        </p:spPr>
+        <p:txBody>
+          <a:bodyPr wrap="none">
+            <a:spAutoFit/>
+          </a:bodyPr>
+          <a:lstStyle/>
+          <a:p>
+            <a:r>
+              <a:rPr sz="1500" b="1">
+                <a:solidFill>
+                  <a:srgbClr val="FFFFFF"/>
+                </a:solidFill>
+                <a:latin typeface="Microsoft YaHei"/>
+              </a:rPr>
+              <a:t>说明</a:t>
+            </a:r>
+          </a:p>
+        </p:txBody>
+      </p:sp>
+      <p:sp>
+        <p:nvSpPr>
+          <p:cNvPr id="11" name="Rounded Rectangle 10"/>
+          <p:cNvSpPr/>
+          <p:nvPr/>
+        </p:nvSpPr>
+        <p:spPr>
+          <a:xfrm>
+            <a:off x="594360" y="2039112"/>
+            <a:ext cx="2331720" cy="576072"/>
+          </a:xfrm>
+          <a:prstGeom prst="roundRect">
+            <a:avLst/>
+          </a:prstGeom>
+          <a:solidFill>
+            <a:srgbClr val="FFFFFF"/>
+          </a:solidFill>
+          <a:ln>
+            <a:solidFill>
+              <a:srgbClr val="CBD5E1"/>
+            </a:solidFill>
+          </a:ln>
+        </p:spPr>
+        <p:style>
+          <a:lnRef idx="1">
+            <a:schemeClr val="accent1"/>
+          </a:lnRef>
+          <a:fillRef idx="3">
+            <a:schemeClr val="accent1"/>
+          </a:fillRef>
+          <a:effectRef idx="2">
+            <a:schemeClr val="accent1"/>
+          </a:effectRef>
+          <a:fontRef idx="minor">
+            <a:schemeClr val="lt1"/>
+          </a:fontRef>
+        </p:style>
+        <p:txBody>
+          <a:bodyPr rtlCol="0" anchor="ctr"/>
+          <a:lstStyle/>
+          <a:p>
+            <a:pPr algn="ctr"/>
+          </a:p>
+        </p:txBody>
+      </p:sp>
+      <p:sp>
+        <p:nvSpPr>
+          <p:cNvPr id="12" name="TextBox 11"/>
+          <p:cNvSpPr txBox="1"/>
+          <p:nvPr/>
+        </p:nvSpPr>
+        <p:spPr>
+          <a:xfrm>
+            <a:off x="667512" y="2084832"/>
+            <a:ext cx="2212848" cy="411480"/>
+          </a:xfrm>
+          <a:prstGeom prst="rect">
+            <a:avLst/>
+          </a:prstGeom>
+          <a:noFill/>
+        </p:spPr>
+        <p:txBody>
+          <a:bodyPr wrap="none">
+            <a:spAutoFit/>
+          </a:bodyPr>
+          <a:lstStyle/>
+          <a:p>
+            <a:r>
+              <a:rPr sz="1300">
+                <a:solidFill>
+                  <a:srgbClr val="0F172A"/>
+                </a:solidFill>
+                <a:latin typeface="Microsoft YaHei"/>
+              </a:rPr>
+              <a:t>你的问题</a:t>
+            </a:r>
+          </a:p>
+        </p:txBody>
+      </p:sp>
+      <p:sp>
+        <p:nvSpPr>
+          <p:cNvPr id="13" name="Rounded Rectangle 12"/>
+          <p:cNvSpPr/>
+          <p:nvPr/>
+        </p:nvSpPr>
+        <p:spPr>
+          <a:xfrm>
+            <a:off x="2971800" y="2039112"/>
+            <a:ext cx="1600200" cy="576072"/>
+          </a:xfrm>
+          <a:prstGeom prst="roundRect">
+            <a:avLst/>
+          </a:prstGeom>
+          <a:solidFill>
+            <a:srgbClr val="FFFFFF"/>
+          </a:solidFill>
+          <a:ln>
+            <a:solidFill>
+              <a:srgbClr val="CBD5E1"/>
+            </a:solidFill>
+          </a:ln>
+        </p:spPr>
+        <p:style>
+          <a:lnRef idx="1">
+            <a:schemeClr val="accent1"/>
+          </a:lnRef>
+          <a:fillRef idx="3">
+            <a:schemeClr val="accent1"/>
+          </a:fillRef>
+          <a:effectRef idx="2">
+            <a:schemeClr val="accent1"/>
+          </a:effectRef>
+          <a:fontRef idx="minor">
+            <a:schemeClr val="lt1"/>
+          </a:fontRef>
+        </p:style>
+        <p:txBody>
+          <a:bodyPr rtlCol="0" anchor="ctr"/>
+          <a:lstStyle/>
+          <a:p>
+            <a:pPr algn="ctr"/>
+          </a:p>
+        </p:txBody>
+      </p:sp>
+      <p:sp>
+        <p:nvSpPr>
+          <p:cNvPr id="14" name="TextBox 13"/>
+          <p:cNvSpPr txBox="1"/>
+          <p:nvPr/>
+        </p:nvSpPr>
+        <p:spPr>
+          <a:xfrm>
+            <a:off x="3044952" y="2084832"/>
+            <a:ext cx="1481328" cy="411480"/>
+          </a:xfrm>
+          <a:prstGeom prst="rect">
+            <a:avLst/>
+          </a:prstGeom>
+          <a:noFill/>
+        </p:spPr>
+        <p:txBody>
+          <a:bodyPr wrap="none">
+            <a:spAutoFit/>
+          </a:bodyPr>
+          <a:lstStyle/>
+          <a:p>
+            <a:r>
+              <a:rPr sz="1300">
+                <a:solidFill>
+                  <a:srgbClr val="0F172A"/>
+                </a:solidFill>
+                <a:latin typeface="Microsoft YaHei"/>
+              </a:rPr>
+              <a:t>最值得先读的文献/资料</a:t>
+            </a:r>
+          </a:p>
+        </p:txBody>
+      </p:sp>
+      <p:sp>
+        <p:nvSpPr>
+          <p:cNvPr id="15" name="Rounded Rectangle 14"/>
+          <p:cNvSpPr/>
+          <p:nvPr/>
+        </p:nvSpPr>
+        <p:spPr>
+          <a:xfrm>
+            <a:off x="4617720" y="2039112"/>
+            <a:ext cx="6812280" cy="576072"/>
+          </a:xfrm>
+          <a:prstGeom prst="roundRect">
+            <a:avLst/>
+          </a:prstGeom>
+          <a:solidFill>
+            <a:srgbClr val="FFFFFF"/>
+          </a:solidFill>
+          <a:ln>
+            <a:solidFill>
+              <a:srgbClr val="CBD5E1"/>
+            </a:solidFill>
+          </a:ln>
+        </p:spPr>
+        <p:style>
+          <a:lnRef idx="1">
+            <a:schemeClr val="accent1"/>
+          </a:lnRef>
+          <a:fillRef idx="3">
+            <a:schemeClr val="accent1"/>
+          </a:fillRef>
+          <a:effectRef idx="2">
+            <a:schemeClr val="accent1"/>
+          </a:effectRef>
+          <a:fontRef idx="minor">
+            <a:schemeClr val="lt1"/>
+          </a:fontRef>
+        </p:style>
+        <p:txBody>
+          <a:bodyPr rtlCol="0" anchor="ctr"/>
+          <a:lstStyle/>
+          <a:p>
+            <a:pPr algn="ctr"/>
+          </a:p>
+        </p:txBody>
+      </p:sp>
+      <p:sp>
+        <p:nvSpPr>
+          <p:cNvPr id="16" name="TextBox 15"/>
+          <p:cNvSpPr txBox="1"/>
+          <p:nvPr/>
+        </p:nvSpPr>
+        <p:spPr>
+          <a:xfrm>
+            <a:off x="4690872" y="2084832"/>
+            <a:ext cx="6693408" cy="411480"/>
+          </a:xfrm>
+          <a:prstGeom prst="rect">
+            <a:avLst/>
+          </a:prstGeom>
+          <a:noFill/>
+        </p:spPr>
+        <p:txBody>
+          <a:bodyPr wrap="none">
+            <a:spAutoFit/>
+          </a:bodyPr>
+          <a:lstStyle/>
+          <a:p>
+            <a:r>
+              <a:rPr sz="1100">
+                <a:solidFill>
+                  <a:srgbClr val="475569"/>
+                </a:solidFill>
+                <a:latin typeface="Microsoft YaHei"/>
+              </a:rPr>
+              <a:t>读它的原因</a:t>
+            </a:r>
+          </a:p>
+        </p:txBody>
+      </p:sp>
+      <p:sp>
+        <p:nvSpPr>
+          <p:cNvPr id="17" name="Rounded Rectangle 16"/>
+          <p:cNvSpPr/>
+          <p:nvPr/>
+        </p:nvSpPr>
+        <p:spPr>
+          <a:xfrm>
+            <a:off x="594360" y="2660904"/>
+            <a:ext cx="2331720" cy="576072"/>
+          </a:xfrm>
+          <a:prstGeom prst="roundRect">
+            <a:avLst/>
+          </a:prstGeom>
+          <a:solidFill>
+            <a:srgbClr val="DBEAFE"/>
+          </a:solidFill>
+          <a:ln>
+            <a:solidFill>
+              <a:srgbClr val="CBD5E1"/>
+            </a:solidFill>
+          </a:ln>
+        </p:spPr>
+        <p:style>
+          <a:lnRef idx="1">
+            <a:schemeClr val="accent1"/>
+          </a:lnRef>
+          <a:fillRef idx="3">
+            <a:schemeClr val="accent1"/>
+          </a:fillRef>
+          <a:effectRef idx="2">
+            <a:schemeClr val="accent1"/>
+          </a:effectRef>
+          <a:fontRef idx="minor">
+            <a:schemeClr val="lt1"/>
+          </a:fontRef>
+        </p:style>
+        <p:txBody>
+          <a:bodyPr rtlCol="0" anchor="ctr"/>
+          <a:lstStyle/>
+          <a:p>
+            <a:pPr algn="ctr"/>
+          </a:p>
+        </p:txBody>
+      </p:sp>
+      <p:sp>
+        <p:nvSpPr>
+          <p:cNvPr id="18" name="TextBox 17"/>
+          <p:cNvSpPr txBox="1"/>
+          <p:nvPr/>
+        </p:nvSpPr>
+        <p:spPr>
+          <a:xfrm>
+            <a:off x="667512" y="2706624"/>
+            <a:ext cx="2212848" cy="411480"/>
+          </a:xfrm>
+          <a:prstGeom prst="rect">
+            <a:avLst/>
+          </a:prstGeom>
+          <a:noFill/>
+        </p:spPr>
+        <p:txBody>
+          <a:bodyPr wrap="none">
+            <a:spAutoFit/>
+          </a:bodyPr>
+          <a:lstStyle/>
+          <a:p>
+            <a:r>
+              <a:rPr sz="1300">
+                <a:solidFill>
+                  <a:srgbClr val="0F172A"/>
+                </a:solidFill>
+                <a:latin typeface="Microsoft YaHei"/>
+              </a:rPr>
+              <a:t>能不能做？</a:t>
+            </a:r>
+          </a:p>
+        </p:txBody>
+      </p:sp>
+      <p:sp>
+        <p:nvSpPr>
+          <p:cNvPr id="19" name="Rounded Rectangle 18"/>
+          <p:cNvSpPr/>
+          <p:nvPr/>
+        </p:nvSpPr>
+        <p:spPr>
+          <a:xfrm>
+            <a:off x="2971800" y="2660904"/>
+            <a:ext cx="1600200" cy="576072"/>
+          </a:xfrm>
+          <a:prstGeom prst="roundRect">
+            <a:avLst/>
+          </a:prstGeom>
+          <a:solidFill>
+            <a:srgbClr val="DBEAFE"/>
+          </a:solidFill>
+          <a:ln>
+            <a:solidFill>
+              <a:srgbClr val="CBD5E1"/>
+            </a:solidFill>
+          </a:ln>
+        </p:spPr>
+        <p:style>
+          <a:lnRef idx="1">
+            <a:schemeClr val="accent1"/>
+          </a:lnRef>
+          <a:fillRef idx="3">
+            <a:schemeClr val="accent1"/>
+          </a:fillRef>
+          <a:effectRef idx="2">
+            <a:schemeClr val="accent1"/>
+          </a:effectRef>
+          <a:fontRef idx="minor">
+            <a:schemeClr val="lt1"/>
+          </a:fontRef>
+        </p:style>
+        <p:txBody>
+          <a:bodyPr rtlCol="0" anchor="ctr"/>
+          <a:lstStyle/>
+          <a:p>
+            <a:pPr algn="ctr"/>
+          </a:p>
+        </p:txBody>
+      </p:sp>
+      <p:sp>
+        <p:nvSpPr>
+          <p:cNvPr id="20" name="TextBox 19"/>
+          <p:cNvSpPr txBox="1"/>
+          <p:nvPr/>
+        </p:nvSpPr>
+        <p:spPr>
+          <a:xfrm>
+            <a:off x="3044952" y="2706624"/>
+            <a:ext cx="1481328" cy="411480"/>
+          </a:xfrm>
+          <a:prstGeom prst="rect">
+            <a:avLst/>
+          </a:prstGeom>
+          <a:noFill/>
+        </p:spPr>
+        <p:txBody>
+          <a:bodyPr wrap="none">
+            <a:spAutoFit/>
+          </a:bodyPr>
+          <a:lstStyle/>
+          <a:p>
+            <a:r>
+              <a:rPr sz="1300">
+                <a:solidFill>
+                  <a:srgbClr val="0F172A"/>
+                </a:solidFill>
+                <a:latin typeface="Microsoft YaHei"/>
+              </a:rPr>
+              <a:t>Brecht et al. 2018；IEEE 1609.2；ETSI TS 102 941</a:t>
+            </a:r>
+          </a:p>
+        </p:txBody>
+      </p:sp>
+      <p:sp>
+        <p:nvSpPr>
+          <p:cNvPr id="21" name="Rounded Rectangle 20"/>
+          <p:cNvSpPr/>
+          <p:nvPr/>
+        </p:nvSpPr>
+        <p:spPr>
+          <a:xfrm>
+            <a:off x="4617720" y="2660904"/>
+            <a:ext cx="6812280" cy="576072"/>
+          </a:xfrm>
+          <a:prstGeom prst="roundRect">
+            <a:avLst/>
+          </a:prstGeom>
+          <a:solidFill>
+            <a:srgbClr val="DBEAFE"/>
+          </a:solidFill>
+          <a:ln>
+            <a:solidFill>
+              <a:srgbClr val="CBD5E1"/>
+            </a:solidFill>
+          </a:ln>
+        </p:spPr>
+        <p:style>
+          <a:lnRef idx="1">
+            <a:schemeClr val="accent1"/>
+          </a:lnRef>
+          <a:fillRef idx="3">
+            <a:schemeClr val="accent1"/>
+          </a:fillRef>
+          <a:effectRef idx="2">
+            <a:schemeClr val="accent1"/>
+          </a:effectRef>
+          <a:fontRef idx="minor">
+            <a:schemeClr val="lt1"/>
+          </a:fontRef>
+        </p:style>
+        <p:txBody>
+          <a:bodyPr rtlCol="0" anchor="ctr"/>
+          <a:lstStyle/>
+          <a:p>
+            <a:pPr algn="ctr"/>
+          </a:p>
+        </p:txBody>
+      </p:sp>
+      <p:sp>
+        <p:nvSpPr>
+          <p:cNvPr id="22" name="TextBox 21"/>
+          <p:cNvSpPr txBox="1"/>
+          <p:nvPr/>
+        </p:nvSpPr>
+        <p:spPr>
+          <a:xfrm>
+            <a:off x="4690872" y="2706624"/>
+            <a:ext cx="6693408" cy="411480"/>
+          </a:xfrm>
+          <a:prstGeom prst="rect">
+            <a:avLst/>
+          </a:prstGeom>
+          <a:noFill/>
+        </p:spPr>
+        <p:txBody>
+          <a:bodyPr wrap="none">
+            <a:spAutoFit/>
+          </a:bodyPr>
+          <a:lstStyle/>
+          <a:p>
+            <a:r>
+              <a:rPr sz="1100">
+                <a:solidFill>
+                  <a:srgbClr val="475569"/>
+                </a:solidFill>
+                <a:latin typeface="Microsoft YaHei"/>
+              </a:rPr>
+              <a:t>给出成熟架构与标准基线</a:t>
+            </a:r>
+          </a:p>
+        </p:txBody>
+      </p:sp>
+      <p:sp>
+        <p:nvSpPr>
+          <p:cNvPr id="23" name="Rounded Rectangle 22"/>
+          <p:cNvSpPr/>
+          <p:nvPr/>
+        </p:nvSpPr>
+        <p:spPr>
+          <a:xfrm>
+            <a:off x="594360" y="3282696"/>
+            <a:ext cx="2331720" cy="576072"/>
+          </a:xfrm>
+          <a:prstGeom prst="roundRect">
+            <a:avLst/>
+          </a:prstGeom>
+          <a:solidFill>
+            <a:srgbClr val="FFFFFF"/>
+          </a:solidFill>
+          <a:ln>
+            <a:solidFill>
+              <a:srgbClr val="CBD5E1"/>
+            </a:solidFill>
+          </a:ln>
+        </p:spPr>
+        <p:style>
+          <a:lnRef idx="1">
+            <a:schemeClr val="accent1"/>
+          </a:lnRef>
+          <a:fillRef idx="3">
+            <a:schemeClr val="accent1"/>
+          </a:fillRef>
+          <a:effectRef idx="2">
+            <a:schemeClr val="accent1"/>
+          </a:effectRef>
+          <a:fontRef idx="minor">
+            <a:schemeClr val="lt1"/>
+          </a:fontRef>
+        </p:style>
+        <p:txBody>
+          <a:bodyPr rtlCol="0" anchor="ctr"/>
+          <a:lstStyle/>
+          <a:p>
+            <a:pPr algn="ctr"/>
+          </a:p>
+        </p:txBody>
+      </p:sp>
+      <p:sp>
+        <p:nvSpPr>
+          <p:cNvPr id="24" name="TextBox 23"/>
+          <p:cNvSpPr txBox="1"/>
+          <p:nvPr/>
+        </p:nvSpPr>
+        <p:spPr>
+          <a:xfrm>
+            <a:off x="667512" y="3328416"/>
+            <a:ext cx="2212848" cy="411480"/>
+          </a:xfrm>
+          <a:prstGeom prst="rect">
+            <a:avLst/>
+          </a:prstGeom>
+          <a:noFill/>
+        </p:spPr>
+        <p:txBody>
+          <a:bodyPr wrap="none">
+            <a:spAutoFit/>
+          </a:bodyPr>
+          <a:lstStyle/>
+          <a:p>
+            <a:r>
+              <a:rPr sz="1300">
+                <a:solidFill>
+                  <a:srgbClr val="0F172A"/>
+                </a:solidFill>
+                <a:latin typeface="Microsoft YaHei"/>
+              </a:rPr>
+              <a:t>用什么密码学？</a:t>
+            </a:r>
+          </a:p>
+        </p:txBody>
+      </p:sp>
+      <p:sp>
+        <p:nvSpPr>
+          <p:cNvPr id="25" name="Rounded Rectangle 24"/>
+          <p:cNvSpPr/>
+          <p:nvPr/>
+        </p:nvSpPr>
+        <p:spPr>
+          <a:xfrm>
+            <a:off x="2971800" y="3282696"/>
+            <a:ext cx="1600200" cy="576072"/>
+          </a:xfrm>
+          <a:prstGeom prst="roundRect">
+            <a:avLst/>
+          </a:prstGeom>
+          <a:solidFill>
+            <a:srgbClr val="FFFFFF"/>
+          </a:solidFill>
+          <a:ln>
+            <a:solidFill>
+              <a:srgbClr val="CBD5E1"/>
+            </a:solidFill>
+          </a:ln>
+        </p:spPr>
+        <p:style>
+          <a:lnRef idx="1">
+            <a:schemeClr val="accent1"/>
+          </a:lnRef>
+          <a:fillRef idx="3">
+            <a:schemeClr val="accent1"/>
+          </a:fillRef>
+          <a:effectRef idx="2">
+            <a:schemeClr val="accent1"/>
+          </a:effectRef>
+          <a:fontRef idx="minor">
+            <a:schemeClr val="lt1"/>
+          </a:fontRef>
+        </p:style>
+        <p:txBody>
+          <a:bodyPr rtlCol="0" anchor="ctr"/>
+          <a:lstStyle/>
+          <a:p>
+            <a:pPr algn="ctr"/>
+          </a:p>
+        </p:txBody>
+      </p:sp>
+      <p:sp>
+        <p:nvSpPr>
+          <p:cNvPr id="26" name="TextBox 25"/>
+          <p:cNvSpPr txBox="1"/>
+          <p:nvPr/>
+        </p:nvSpPr>
+        <p:spPr>
+          <a:xfrm>
+            <a:off x="3044952" y="3328416"/>
+            <a:ext cx="1481328" cy="411480"/>
+          </a:xfrm>
+          <a:prstGeom prst="rect">
+            <a:avLst/>
+          </a:prstGeom>
+          <a:noFill/>
+        </p:spPr>
+        <p:txBody>
+          <a:bodyPr wrap="none">
+            <a:spAutoFit/>
+          </a:bodyPr>
+          <a:lstStyle/>
+          <a:p>
+            <a:r>
+              <a:rPr sz="1300">
+                <a:solidFill>
+                  <a:srgbClr val="0F172A"/>
+                </a:solidFill>
+                <a:latin typeface="Microsoft YaHei"/>
+              </a:rPr>
+              <a:t>IEEE 1609.2；ISO-TC204 Primer；FITSec</a:t>
+            </a:r>
+          </a:p>
+        </p:txBody>
+      </p:sp>
+      <p:sp>
+        <p:nvSpPr>
+          <p:cNvPr id="27" name="Rounded Rectangle 26"/>
+          <p:cNvSpPr/>
+          <p:nvPr/>
+        </p:nvSpPr>
+        <p:spPr>
+          <a:xfrm>
+            <a:off x="4617720" y="3282696"/>
+            <a:ext cx="6812280" cy="576072"/>
+          </a:xfrm>
+          <a:prstGeom prst="roundRect">
+            <a:avLst/>
+          </a:prstGeom>
+          <a:solidFill>
+            <a:srgbClr val="FFFFFF"/>
+          </a:solidFill>
+          <a:ln>
+            <a:solidFill>
+              <a:srgbClr val="CBD5E1"/>
+            </a:solidFill>
+          </a:ln>
+        </p:spPr>
+        <p:style>
+          <a:lnRef idx="1">
+            <a:schemeClr val="accent1"/>
+          </a:lnRef>
+          <a:fillRef idx="3">
+            <a:schemeClr val="accent1"/>
+          </a:fillRef>
+          <a:effectRef idx="2">
+            <a:schemeClr val="accent1"/>
+          </a:effectRef>
+          <a:fontRef idx="minor">
+            <a:schemeClr val="lt1"/>
+          </a:fontRef>
+        </p:style>
+        <p:txBody>
+          <a:bodyPr rtlCol="0" anchor="ctr"/>
+          <a:lstStyle/>
+          <a:p>
+            <a:pPr algn="ctr"/>
+          </a:p>
+        </p:txBody>
+      </p:sp>
+      <p:sp>
+        <p:nvSpPr>
+          <p:cNvPr id="28" name="TextBox 27"/>
+          <p:cNvSpPr txBox="1"/>
+          <p:nvPr/>
+        </p:nvSpPr>
+        <p:spPr>
+          <a:xfrm>
+            <a:off x="4690872" y="3328416"/>
+            <a:ext cx="6693408" cy="411480"/>
+          </a:xfrm>
+          <a:prstGeom prst="rect">
+            <a:avLst/>
+          </a:prstGeom>
+          <a:noFill/>
+        </p:spPr>
+        <p:txBody>
+          <a:bodyPr wrap="none">
+            <a:spAutoFit/>
+          </a:bodyPr>
+          <a:lstStyle/>
+          <a:p>
+            <a:r>
+              <a:rPr sz="1100">
+                <a:solidFill>
+                  <a:srgbClr val="475569"/>
+                </a:solidFill>
+                <a:latin typeface="Microsoft YaHei"/>
+              </a:rPr>
+              <a:t>明确 ECC、伪名证书、证书轮换的主流路线</a:t>
+            </a:r>
+          </a:p>
+        </p:txBody>
+      </p:sp>
+      <p:sp>
+        <p:nvSpPr>
+          <p:cNvPr id="29" name="Rounded Rectangle 28"/>
+          <p:cNvSpPr/>
+          <p:nvPr/>
+        </p:nvSpPr>
+        <p:spPr>
+          <a:xfrm>
+            <a:off x="594360" y="3904488"/>
+            <a:ext cx="2331720" cy="576072"/>
+          </a:xfrm>
+          <a:prstGeom prst="roundRect">
+            <a:avLst/>
+          </a:prstGeom>
+          <a:solidFill>
+            <a:srgbClr val="DBEAFE"/>
+          </a:solidFill>
+          <a:ln>
+            <a:solidFill>
+              <a:srgbClr val="CBD5E1"/>
+            </a:solidFill>
+          </a:ln>
+        </p:spPr>
+        <p:style>
+          <a:lnRef idx="1">
+            <a:schemeClr val="accent1"/>
+          </a:lnRef>
+          <a:fillRef idx="3">
+            <a:schemeClr val="accent1"/>
+          </a:fillRef>
+          <a:effectRef idx="2">
+            <a:schemeClr val="accent1"/>
+          </a:effectRef>
+          <a:fontRef idx="minor">
+            <a:schemeClr val="lt1"/>
+          </a:fontRef>
+        </p:style>
+        <p:txBody>
+          <a:bodyPr rtlCol="0" anchor="ctr"/>
+          <a:lstStyle/>
+          <a:p>
+            <a:pPr algn="ctr"/>
+          </a:p>
+        </p:txBody>
+      </p:sp>
+      <p:sp>
+        <p:nvSpPr>
+          <p:cNvPr id="30" name="TextBox 29"/>
+          <p:cNvSpPr txBox="1"/>
+          <p:nvPr/>
+        </p:nvSpPr>
+        <p:spPr>
+          <a:xfrm>
+            <a:off x="667512" y="3950208"/>
+            <a:ext cx="2212848" cy="411480"/>
+          </a:xfrm>
+          <a:prstGeom prst="rect">
+            <a:avLst/>
+          </a:prstGeom>
+          <a:noFill/>
+        </p:spPr>
+        <p:txBody>
+          <a:bodyPr wrap="none">
+            <a:spAutoFit/>
+          </a:bodyPr>
+          <a:lstStyle/>
+          <a:p>
+            <a:r>
+              <a:rPr sz="1300">
+                <a:solidFill>
+                  <a:srgbClr val="0F172A"/>
+                </a:solidFill>
+                <a:latin typeface="Microsoft YaHei"/>
+              </a:rPr>
+              <a:t>实时撤销怎么做？</a:t>
+            </a:r>
+          </a:p>
+        </p:txBody>
+      </p:sp>
+      <p:sp>
+        <p:nvSpPr>
+          <p:cNvPr id="31" name="Rounded Rectangle 30"/>
+          <p:cNvSpPr/>
+          <p:nvPr/>
+        </p:nvSpPr>
+        <p:spPr>
+          <a:xfrm>
+            <a:off x="2971800" y="3904488"/>
+            <a:ext cx="1600200" cy="576072"/>
+          </a:xfrm>
+          <a:prstGeom prst="roundRect">
+            <a:avLst/>
+          </a:prstGeom>
+          <a:solidFill>
+            <a:srgbClr val="DBEAFE"/>
+          </a:solidFill>
+          <a:ln>
+            <a:solidFill>
+              <a:srgbClr val="CBD5E1"/>
+            </a:solidFill>
+          </a:ln>
+        </p:spPr>
+        <p:style>
+          <a:lnRef idx="1">
+            <a:schemeClr val="accent1"/>
+          </a:lnRef>
+          <a:fillRef idx="3">
+            <a:schemeClr val="accent1"/>
+          </a:fillRef>
+          <a:effectRef idx="2">
+            <a:schemeClr val="accent1"/>
+          </a:effectRef>
+          <a:fontRef idx="minor">
+            <a:schemeClr val="lt1"/>
+          </a:fontRef>
+        </p:style>
+        <p:txBody>
+          <a:bodyPr rtlCol="0" anchor="ctr"/>
+          <a:lstStyle/>
+          <a:p>
+            <a:pPr algn="ctr"/>
+          </a:p>
+        </p:txBody>
+      </p:sp>
+      <p:sp>
+        <p:nvSpPr>
+          <p:cNvPr id="32" name="TextBox 31"/>
+          <p:cNvSpPr txBox="1"/>
+          <p:nvPr/>
+        </p:nvSpPr>
+        <p:spPr>
+          <a:xfrm>
+            <a:off x="3044952" y="3950208"/>
+            <a:ext cx="1481328" cy="411480"/>
+          </a:xfrm>
+          <a:prstGeom prst="rect">
+            <a:avLst/>
+          </a:prstGeom>
+          <a:noFill/>
+        </p:spPr>
+        <p:txBody>
+          <a:bodyPr wrap="none">
+            <a:spAutoFit/>
+          </a:bodyPr>
+          <a:lstStyle/>
+          <a:p>
+            <a:r>
+              <a:rPr sz="1300">
+                <a:solidFill>
+                  <a:srgbClr val="0F172A"/>
+                </a:solidFill>
+                <a:latin typeface="Microsoft YaHei"/>
+              </a:rPr>
+              <a:t>ISO-TC204 Primer；ETSI TS 103 759；Chen et al. 2023</a:t>
+            </a:r>
+          </a:p>
+        </p:txBody>
+      </p:sp>
+      <p:sp>
+        <p:nvSpPr>
+          <p:cNvPr id="33" name="Rounded Rectangle 32"/>
+          <p:cNvSpPr/>
+          <p:nvPr/>
+        </p:nvSpPr>
+        <p:spPr>
+          <a:xfrm>
+            <a:off x="4617720" y="3904488"/>
+            <a:ext cx="6812280" cy="576072"/>
+          </a:xfrm>
+          <a:prstGeom prst="roundRect">
+            <a:avLst/>
+          </a:prstGeom>
+          <a:solidFill>
+            <a:srgbClr val="DBEAFE"/>
+          </a:solidFill>
+          <a:ln>
+            <a:solidFill>
+              <a:srgbClr val="CBD5E1"/>
+            </a:solidFill>
+          </a:ln>
+        </p:spPr>
+        <p:style>
+          <a:lnRef idx="1">
+            <a:schemeClr val="accent1"/>
+          </a:lnRef>
+          <a:fillRef idx="3">
+            <a:schemeClr val="accent1"/>
+          </a:fillRef>
+          <a:effectRef idx="2">
+            <a:schemeClr val="accent1"/>
+          </a:effectRef>
+          <a:fontRef idx="minor">
+            <a:schemeClr val="lt1"/>
+          </a:fontRef>
+        </p:style>
+        <p:txBody>
+          <a:bodyPr rtlCol="0" anchor="ctr"/>
+          <a:lstStyle/>
+          <a:p>
+            <a:pPr algn="ctr"/>
+          </a:p>
+        </p:txBody>
+      </p:sp>
+      <p:sp>
+        <p:nvSpPr>
+          <p:cNvPr id="34" name="TextBox 33"/>
+          <p:cNvSpPr txBox="1"/>
+          <p:nvPr/>
+        </p:nvSpPr>
+        <p:spPr>
+          <a:xfrm>
+            <a:off x="4690872" y="3950208"/>
+            <a:ext cx="6693408" cy="411480"/>
+          </a:xfrm>
+          <a:prstGeom prst="rect">
+            <a:avLst/>
+          </a:prstGeom>
+          <a:noFill/>
+        </p:spPr>
+        <p:txBody>
+          <a:bodyPr wrap="none">
+            <a:spAutoFit/>
+          </a:bodyPr>
+          <a:lstStyle/>
+          <a:p>
+            <a:r>
+              <a:rPr sz="1100">
+                <a:solidFill>
+                  <a:srgbClr val="475569"/>
+                </a:solidFill>
+                <a:latin typeface="Microsoft YaHei"/>
+              </a:rPr>
+              <a:t>把 CRL/CTL、误行为报告、实现性能串起来</a:t>
+            </a:r>
+          </a:p>
+        </p:txBody>
+      </p:sp>
+      <p:sp>
+        <p:nvSpPr>
+          <p:cNvPr id="35" name="Rounded Rectangle 34"/>
+          <p:cNvSpPr/>
+          <p:nvPr/>
+        </p:nvSpPr>
+        <p:spPr>
+          <a:xfrm>
+            <a:off x="594360" y="4526280"/>
+            <a:ext cx="2331720" cy="576072"/>
+          </a:xfrm>
+          <a:prstGeom prst="roundRect">
+            <a:avLst/>
+          </a:prstGeom>
+          <a:solidFill>
+            <a:srgbClr val="FFFFFF"/>
+          </a:solidFill>
+          <a:ln>
+            <a:solidFill>
+              <a:srgbClr val="CBD5E1"/>
+            </a:solidFill>
+          </a:ln>
+        </p:spPr>
+        <p:style>
+          <a:lnRef idx="1">
+            <a:schemeClr val="accent1"/>
+          </a:lnRef>
+          <a:fillRef idx="3">
+            <a:schemeClr val="accent1"/>
+          </a:fillRef>
+          <a:effectRef idx="2">
+            <a:schemeClr val="accent1"/>
+          </a:effectRef>
+          <a:fontRef idx="minor">
+            <a:schemeClr val="lt1"/>
+          </a:fontRef>
+        </p:style>
+        <p:txBody>
+          <a:bodyPr rtlCol="0" anchor="ctr"/>
+          <a:lstStyle/>
+          <a:p>
+            <a:pPr algn="ctr"/>
+          </a:p>
+        </p:txBody>
+      </p:sp>
+      <p:sp>
+        <p:nvSpPr>
+          <p:cNvPr id="36" name="TextBox 35"/>
+          <p:cNvSpPr txBox="1"/>
+          <p:nvPr/>
+        </p:nvSpPr>
+        <p:spPr>
+          <a:xfrm>
+            <a:off x="667512" y="4572000"/>
+            <a:ext cx="2212848" cy="411480"/>
+          </a:xfrm>
+          <a:prstGeom prst="rect">
+            <a:avLst/>
+          </a:prstGeom>
+          <a:noFill/>
+        </p:spPr>
+        <p:txBody>
+          <a:bodyPr wrap="none">
+            <a:spAutoFit/>
+          </a:bodyPr>
+          <a:lstStyle/>
+          <a:p>
+            <a:r>
+              <a:rPr sz="1300">
+                <a:solidFill>
+                  <a:srgbClr val="0F172A"/>
+                </a:solidFill>
+                <a:latin typeface="Microsoft YaHei"/>
+              </a:rPr>
+              <a:t>事后追责怎么做？</a:t>
+            </a:r>
+          </a:p>
+        </p:txBody>
+      </p:sp>
+      <p:sp>
+        <p:nvSpPr>
+          <p:cNvPr id="37" name="Rounded Rectangle 36"/>
+          <p:cNvSpPr/>
+          <p:nvPr/>
+        </p:nvSpPr>
+        <p:spPr>
+          <a:xfrm>
+            <a:off x="2971800" y="4526280"/>
+            <a:ext cx="1600200" cy="576072"/>
+          </a:xfrm>
+          <a:prstGeom prst="roundRect">
+            <a:avLst/>
+          </a:prstGeom>
+          <a:solidFill>
+            <a:srgbClr val="FFFFFF"/>
+          </a:solidFill>
+          <a:ln>
+            <a:solidFill>
+              <a:srgbClr val="CBD5E1"/>
+            </a:solidFill>
+          </a:ln>
+        </p:spPr>
+        <p:style>
+          <a:lnRef idx="1">
+            <a:schemeClr val="accent1"/>
+          </a:lnRef>
+          <a:fillRef idx="3">
+            <a:schemeClr val="accent1"/>
+          </a:fillRef>
+          <a:effectRef idx="2">
+            <a:schemeClr val="accent1"/>
+          </a:effectRef>
+          <a:fontRef idx="minor">
+            <a:schemeClr val="lt1"/>
+          </a:fontRef>
+        </p:style>
+        <p:txBody>
+          <a:bodyPr rtlCol="0" anchor="ctr"/>
+          <a:lstStyle/>
+          <a:p>
+            <a:pPr algn="ctr"/>
+          </a:p>
+        </p:txBody>
+      </p:sp>
+      <p:sp>
+        <p:nvSpPr>
+          <p:cNvPr id="38" name="TextBox 37"/>
+          <p:cNvSpPr txBox="1"/>
+          <p:nvPr/>
+        </p:nvSpPr>
+        <p:spPr>
+          <a:xfrm>
+            <a:off x="3044952" y="4572000"/>
+            <a:ext cx="1481328" cy="411480"/>
+          </a:xfrm>
+          <a:prstGeom prst="rect">
+            <a:avLst/>
+          </a:prstGeom>
+          <a:noFill/>
+        </p:spPr>
+        <p:txBody>
+          <a:bodyPr wrap="none">
+            <a:spAutoFit/>
+          </a:bodyPr>
+          <a:lstStyle/>
+          <a:p>
+            <a:r>
+              <a:rPr sz="1300">
+                <a:solidFill>
+                  <a:srgbClr val="0F172A"/>
+                </a:solidFill>
+                <a:latin typeface="Microsoft YaHei"/>
+              </a:rPr>
+              <a:t>OpenSCMS LA；Brecht et al. 2018；ISO-TC204 Primer</a:t>
+            </a:r>
+          </a:p>
+        </p:txBody>
+      </p:sp>
+      <p:sp>
+        <p:nvSpPr>
+          <p:cNvPr id="39" name="Rounded Rectangle 38"/>
+          <p:cNvSpPr/>
+          <p:nvPr/>
+        </p:nvSpPr>
+        <p:spPr>
+          <a:xfrm>
+            <a:off x="4617720" y="4526280"/>
+            <a:ext cx="6812280" cy="576072"/>
+          </a:xfrm>
+          <a:prstGeom prst="roundRect">
+            <a:avLst/>
+          </a:prstGeom>
+          <a:solidFill>
+            <a:srgbClr val="FFFFFF"/>
+          </a:solidFill>
+          <a:ln>
+            <a:solidFill>
+              <a:srgbClr val="CBD5E1"/>
+            </a:solidFill>
+          </a:ln>
+        </p:spPr>
+        <p:style>
+          <a:lnRef idx="1">
+            <a:schemeClr val="accent1"/>
+          </a:lnRef>
+          <a:fillRef idx="3">
+            <a:schemeClr val="accent1"/>
+          </a:fillRef>
+          <a:effectRef idx="2">
+            <a:schemeClr val="accent1"/>
+          </a:effectRef>
+          <a:fontRef idx="minor">
+            <a:schemeClr val="lt1"/>
+          </a:fontRef>
+        </p:style>
+        <p:txBody>
+          <a:bodyPr rtlCol="0" anchor="ctr"/>
+          <a:lstStyle/>
+          <a:p>
+            <a:pPr algn="ctr"/>
+          </a:p>
+        </p:txBody>
+      </p:sp>
+      <p:sp>
+        <p:nvSpPr>
+          <p:cNvPr id="40" name="TextBox 39"/>
+          <p:cNvSpPr txBox="1"/>
+          <p:nvPr/>
+        </p:nvSpPr>
+        <p:spPr>
+          <a:xfrm>
+            <a:off x="4690872" y="4572000"/>
+            <a:ext cx="6693408" cy="411480"/>
+          </a:xfrm>
+          <a:prstGeom prst="rect">
+            <a:avLst/>
+          </a:prstGeom>
+          <a:noFill/>
+        </p:spPr>
+        <p:txBody>
+          <a:bodyPr wrap="none">
+            <a:spAutoFit/>
+          </a:bodyPr>
+          <a:lstStyle/>
+          <a:p>
+            <a:r>
+              <a:rPr sz="1100">
+                <a:solidFill>
+                  <a:srgbClr val="475569"/>
+                </a:solidFill>
+                <a:latin typeface="Microsoft YaHei"/>
+              </a:rPr>
+              <a:t>解释条件开链、linkage values、多机构协作</a:t>
+            </a:r>
+          </a:p>
+        </p:txBody>
+      </p:sp>
+      <p:sp>
+        <p:nvSpPr>
+          <p:cNvPr id="41" name="Rounded Rectangle 40"/>
+          <p:cNvSpPr/>
+          <p:nvPr/>
+        </p:nvSpPr>
+        <p:spPr>
+          <a:xfrm>
+            <a:off x="594360" y="5148072"/>
+            <a:ext cx="2331720" cy="576072"/>
+          </a:xfrm>
+          <a:prstGeom prst="roundRect">
+            <a:avLst/>
+          </a:prstGeom>
+          <a:solidFill>
+            <a:srgbClr val="DBEAFE"/>
+          </a:solidFill>
+          <a:ln>
+            <a:solidFill>
+              <a:srgbClr val="CBD5E1"/>
+            </a:solidFill>
+          </a:ln>
+        </p:spPr>
+        <p:style>
+          <a:lnRef idx="1">
+            <a:schemeClr val="accent1"/>
+          </a:lnRef>
+          <a:fillRef idx="3">
+            <a:schemeClr val="accent1"/>
+          </a:fillRef>
+          <a:effectRef idx="2">
+            <a:schemeClr val="accent1"/>
+          </a:effectRef>
+          <a:fontRef idx="minor">
+            <a:schemeClr val="lt1"/>
+          </a:fontRef>
+        </p:style>
+        <p:txBody>
+          <a:bodyPr rtlCol="0" anchor="ctr"/>
+          <a:lstStyle/>
+          <a:p>
+            <a:pPr algn="ctr"/>
+          </a:p>
+        </p:txBody>
+      </p:sp>
+      <p:sp>
+        <p:nvSpPr>
+          <p:cNvPr id="42" name="TextBox 41"/>
+          <p:cNvSpPr txBox="1"/>
+          <p:nvPr/>
+        </p:nvSpPr>
+        <p:spPr>
+          <a:xfrm>
+            <a:off x="667512" y="5193792"/>
+            <a:ext cx="2212848" cy="411480"/>
+          </a:xfrm>
+          <a:prstGeom prst="rect">
+            <a:avLst/>
+          </a:prstGeom>
+          <a:noFill/>
+        </p:spPr>
+        <p:txBody>
+          <a:bodyPr wrap="none">
+            <a:spAutoFit/>
+          </a:bodyPr>
+          <a:lstStyle/>
+          <a:p>
+            <a:r>
+              <a:rPr sz="1300">
+                <a:solidFill>
+                  <a:srgbClr val="0F172A"/>
+                </a:solidFill>
+                <a:latin typeface="Microsoft YaHei"/>
+              </a:rPr>
+              <a:t>弱硬件能不能扛住？</a:t>
+            </a:r>
+          </a:p>
+        </p:txBody>
+      </p:sp>
+      <p:sp>
+        <p:nvSpPr>
+          <p:cNvPr id="43" name="Rounded Rectangle 42"/>
+          <p:cNvSpPr/>
+          <p:nvPr/>
+        </p:nvSpPr>
+        <p:spPr>
+          <a:xfrm>
+            <a:off x="2971800" y="5148072"/>
+            <a:ext cx="1600200" cy="576072"/>
+          </a:xfrm>
+          <a:prstGeom prst="roundRect">
+            <a:avLst/>
+          </a:prstGeom>
+          <a:solidFill>
+            <a:srgbClr val="DBEAFE"/>
+          </a:solidFill>
+          <a:ln>
+            <a:solidFill>
+              <a:srgbClr val="CBD5E1"/>
+            </a:solidFill>
+          </a:ln>
+        </p:spPr>
+        <p:style>
+          <a:lnRef idx="1">
+            <a:schemeClr val="accent1"/>
+          </a:lnRef>
+          <a:fillRef idx="3">
+            <a:schemeClr val="accent1"/>
+          </a:fillRef>
+          <a:effectRef idx="2">
+            <a:schemeClr val="accent1"/>
+          </a:effectRef>
+          <a:fontRef idx="minor">
+            <a:schemeClr val="lt1"/>
+          </a:fontRef>
+        </p:style>
+        <p:txBody>
+          <a:bodyPr rtlCol="0" anchor="ctr"/>
+          <a:lstStyle/>
+          <a:p>
+            <a:pPr algn="ctr"/>
+          </a:p>
+        </p:txBody>
+      </p:sp>
+      <p:sp>
+        <p:nvSpPr>
+          <p:cNvPr id="44" name="TextBox 43"/>
+          <p:cNvSpPr txBox="1"/>
+          <p:nvPr/>
+        </p:nvSpPr>
+        <p:spPr>
+          <a:xfrm>
+            <a:off x="3044952" y="5193792"/>
+            <a:ext cx="1481328" cy="411480"/>
+          </a:xfrm>
+          <a:prstGeom prst="rect">
+            <a:avLst/>
+          </a:prstGeom>
+          <a:noFill/>
+        </p:spPr>
+        <p:txBody>
+          <a:bodyPr wrap="none">
+            <a:spAutoFit/>
+          </a:bodyPr>
+          <a:lstStyle/>
+          <a:p>
+            <a:r>
+              <a:rPr sz="1300">
+                <a:solidFill>
+                  <a:srgbClr val="0F172A"/>
+                </a:solidFill>
+                <a:latin typeface="Microsoft YaHei"/>
+              </a:rPr>
+              <a:t>FITSec；Amjad et al. 2018；Chen et al. 2023</a:t>
+            </a:r>
+          </a:p>
+        </p:txBody>
+      </p:sp>
+      <p:sp>
+        <p:nvSpPr>
+          <p:cNvPr id="45" name="Rounded Rectangle 44"/>
+          <p:cNvSpPr/>
+          <p:nvPr/>
+        </p:nvSpPr>
+        <p:spPr>
+          <a:xfrm>
+            <a:off x="4617720" y="5148072"/>
+            <a:ext cx="6812280" cy="576072"/>
+          </a:xfrm>
+          <a:prstGeom prst="roundRect">
+            <a:avLst/>
+          </a:prstGeom>
+          <a:solidFill>
+            <a:srgbClr val="DBEAFE"/>
+          </a:solidFill>
+          <a:ln>
+            <a:solidFill>
+              <a:srgbClr val="CBD5E1"/>
+            </a:solidFill>
+          </a:ln>
+        </p:spPr>
+        <p:style>
+          <a:lnRef idx="1">
+            <a:schemeClr val="accent1"/>
+          </a:lnRef>
+          <a:fillRef idx="3">
+            <a:schemeClr val="accent1"/>
+          </a:fillRef>
+          <a:effectRef idx="2">
+            <a:schemeClr val="accent1"/>
+          </a:effectRef>
+          <a:fontRef idx="minor">
+            <a:schemeClr val="lt1"/>
+          </a:fontRef>
+        </p:style>
+        <p:txBody>
+          <a:bodyPr rtlCol="0" anchor="ctr"/>
+          <a:lstStyle/>
+          <a:p>
+            <a:pPr algn="ctr"/>
+          </a:p>
+        </p:txBody>
+      </p:sp>
+      <p:sp>
+        <p:nvSpPr>
+          <p:cNvPr id="46" name="TextBox 45"/>
+          <p:cNvSpPr txBox="1"/>
+          <p:nvPr/>
+        </p:nvSpPr>
+        <p:spPr>
+          <a:xfrm>
+            <a:off x="4690872" y="5193792"/>
+            <a:ext cx="6693408" cy="411480"/>
+          </a:xfrm>
+          <a:prstGeom prst="rect">
+            <a:avLst/>
+          </a:prstGeom>
+          <a:noFill/>
+        </p:spPr>
+        <p:txBody>
+          <a:bodyPr wrap="none">
+            <a:spAutoFit/>
+          </a:bodyPr>
+          <a:lstStyle/>
+          <a:p>
+            <a:r>
+              <a:rPr sz="1100">
+                <a:solidFill>
+                  <a:srgbClr val="475569"/>
+                </a:solidFill>
+                <a:latin typeface="Microsoft YaHei"/>
+              </a:rPr>
+              <a:t>一边看资源约束，一边看性能与时延</a:t>
+            </a:r>
+          </a:p>
+        </p:txBody>
+      </p:sp>
+      <p:sp>
+        <p:nvSpPr>
+          <p:cNvPr id="47" name="TextBox 46"/>
+          <p:cNvSpPr txBox="1"/>
+          <p:nvPr/>
+        </p:nvSpPr>
+        <p:spPr>
+          <a:xfrm>
+            <a:off x="685800" y="5486400"/>
+            <a:ext cx="10972800" cy="502920"/>
+          </a:xfrm>
+          <a:prstGeom prst="rect">
+            <a:avLst/>
+          </a:prstGeom>
+          <a:noFill/>
+        </p:spPr>
+        <p:txBody>
+          <a:bodyPr wrap="none">
+            <a:spAutoFit/>
+          </a:bodyPr>
+          <a:lstStyle/>
+          <a:p>
+            <a:r>
+              <a:rPr sz="1600" b="1">
+                <a:solidFill>
+                  <a:srgbClr val="2563EB"/>
+                </a:solidFill>
+                <a:latin typeface="Microsoft YaHei"/>
+              </a:rPr>
+              <a:t>#### 1) 架构与信任根 #### 2) 撤销与分发 #### 3) 隐私保护与事后追责 #### 4) 实时性与弱硬件可行性 一句话建议：如果你接下来要写开题或汇报，最稳的方式不是先“发明一个新密码学方案”，而是先把 标准 → SCMS 架构 → 撤销传播 → 条件追责 → 性能约束 这条文献链讲顺。</a:t>
+            </a:r>
+          </a:p>
+        </p:txBody>
+      </p:sp>
+      <p:sp>
+        <p:nvSpPr>
+          <p:cNvPr id="48" name="TextBox 47"/>
+          <p:cNvSpPr txBox="1"/>
+          <p:nvPr/>
+        </p:nvSpPr>
+        <p:spPr>
+          <a:xfrm>
+            <a:off x="594360" y="6236208"/>
+            <a:ext cx="10972800" cy="228600"/>
+          </a:xfrm>
+          <a:prstGeom prst="rect">
+            <a:avLst/>
+          </a:prstGeom>
+          <a:noFill/>
+        </p:spPr>
+        <p:txBody>
+          <a:bodyPr wrap="none">
+            <a:spAutoFit/>
+          </a:bodyPr>
+          <a:lstStyle/>
+          <a:p>
+            <a:pPr algn="r"/>
+            <a:r>
+              <a:rPr sz="900">
+                <a:solidFill>
+                  <a:srgbClr val="64748B"/>
+                </a:solidFill>
+                <a:latin typeface="Microsoft YaHei"/>
+              </a:rPr>
+              <a:t>参考：[R10][R11][R12][R13][R1][R2][R5][R7][R8][R9]</a:t>
+            </a:r>
+          </a:p>
+        </p:txBody>
+      </p:sp>
+    </p:spTree>
+  </p:cSld>
+  <p:clrMapOvr>
+    <a:masterClrMapping/>
+  </p:clrMapOvr>
+</p:sld>
+</file>
+
+<file path=ppt/slides/slide14.xml><?xml version="1.0" encoding="utf-8"?>
+<p:sld xmlns:a="http://schemas.openxmlformats.org/drawingml/2006/main" xmlns:p="http://schemas.openxmlformats.org/presentationml/2006/main" xmlns:r="http://schemas.openxmlformats.org/officeDocument/2006/relationships">
+  <p:cSld>
+    <p:spTree>
+      <p:nvGrpSpPr>
+        <p:cNvPr id="1" name=""/>
+        <p:cNvGrpSpPr/>
+        <p:nvPr/>
+      </p:nvGrpSpPr>
+      <p:grpSpPr/>
+      <p:sp>
+        <p:nvSpPr>
+          <p:cNvPr id="2" name="Rectangle 1"/>
+          <p:cNvSpPr/>
+          <p:nvPr/>
+        </p:nvSpPr>
+        <p:spPr>
+          <a:xfrm>
+            <a:off x="0" y="0"/>
+            <a:ext cx="12191695" cy="6858000"/>
+          </a:xfrm>
+          <a:prstGeom prst="rect">
+            <a:avLst/>
+          </a:prstGeom>
+          <a:solidFill>
+            <a:srgbClr val="F8FAFC"/>
+          </a:solidFill>
+          <a:ln>
+            <a:noFill/>
+          </a:ln>
+          <a:effectLst/>
+        </p:spPr>
+        <p:style>
+          <a:lnRef idx="1">
+            <a:schemeClr val="accent1"/>
+          </a:lnRef>
+          <a:fillRef idx="3">
+            <a:schemeClr val="accent1"/>
+          </a:fillRef>
+          <a:effectRef idx="2">
+            <a:schemeClr val="accent1"/>
+          </a:effectRef>
+          <a:fontRef idx="minor">
+            <a:schemeClr val="lt1"/>
+          </a:fontRef>
+        </p:style>
+        <p:txBody>
+          <a:bodyPr rtlCol="0" anchor="ctr"/>
+          <a:lstStyle/>
+          <a:p>
+            <a:pPr algn="ctr"/>
+          </a:p>
+        </p:txBody>
+      </p:sp>
+      <p:sp>
+        <p:nvSpPr>
+          <p:cNvPr id="3" name="Rectangle 2"/>
+          <p:cNvSpPr/>
+          <p:nvPr/>
+        </p:nvSpPr>
+        <p:spPr>
+          <a:xfrm>
+            <a:off x="0" y="0"/>
+            <a:ext cx="12191695" cy="640080"/>
+          </a:xfrm>
+          <a:prstGeom prst="rect">
+            <a:avLst/>
+          </a:prstGeom>
+          <a:solidFill>
+            <a:srgbClr val="0F172A"/>
+          </a:solidFill>
+          <a:ln>
+            <a:noFill/>
+          </a:ln>
+        </p:spPr>
+        <p:style>
+          <a:lnRef idx="1">
+            <a:schemeClr val="accent1"/>
+          </a:lnRef>
+          <a:fillRef idx="3">
+            <a:schemeClr val="accent1"/>
+          </a:fillRef>
+          <a:effectRef idx="2">
+            <a:schemeClr val="accent1"/>
+          </a:effectRef>
+          <a:fontRef idx="minor">
+            <a:schemeClr val="lt1"/>
+          </a:fontRef>
+        </p:style>
+        <p:txBody>
+          <a:bodyPr rtlCol="0" anchor="ctr"/>
+          <a:lstStyle/>
+          <a:p>
+            <a:pPr algn="ctr"/>
+          </a:p>
+        </p:txBody>
+      </p:sp>
+      <p:sp>
+        <p:nvSpPr>
+          <p:cNvPr id="4" name="TextBox 3"/>
+          <p:cNvSpPr txBox="1"/>
+          <p:nvPr/>
+        </p:nvSpPr>
+        <p:spPr>
+          <a:xfrm>
+            <a:off x="502920" y="109728"/>
+            <a:ext cx="10972800" cy="365760"/>
+          </a:xfrm>
+          <a:prstGeom prst="rect">
+            <a:avLst/>
+          </a:prstGeom>
+          <a:noFill/>
+        </p:spPr>
+        <p:txBody>
+          <a:bodyPr wrap="none">
+            <a:spAutoFit/>
+          </a:bodyPr>
+          <a:lstStyle/>
+          <a:p>
+            <a:r>
+              <a:rPr sz="2400" b="1">
+                <a:solidFill>
+                  <a:srgbClr val="FFFFFF"/>
+                </a:solidFill>
+                <a:latin typeface="Microsoft YaHei"/>
+              </a:rPr>
+              <a:t>13. 参考资料（可直接放到答辩/PPT 最后一页）</a:t>
             </a:r>
           </a:p>
         </p:txBody>
@@ -4814,7 +6682,7 @@
         <p:spPr>
           <a:xfrm>
             <a:off x="685800" y="1234440"/>
-            <a:ext cx="10972800" cy="4754880"/>
+            <a:ext cx="10972800" cy="4846320"/>
           </a:xfrm>
           <a:prstGeom prst="rect">
             <a:avLst/>
@@ -4829,14 +6697,14 @@
           <a:p>
             <a:pPr>
               <a:spcBef>
-                <a:spcPts val="200"/>
-              </a:spcBef>
-              <a:spcAft>
-                <a:spcPts val="500"/>
-              </a:spcAft>
-            </a:pPr>
-            <a:r>
-              <a:rPr sz="1800">
+                <a:spcPts val="100"/>
+              </a:spcBef>
+              <a:spcAft>
+                <a:spcPts val="400"/>
+              </a:spcAft>
+            </a:pPr>
+            <a:r>
+              <a:rPr sz="1600">
                 <a:solidFill>
                   <a:srgbClr val="0F172A"/>
                 </a:solidFill>
@@ -4848,14 +6716,14 @@
           <a:p>
             <a:pPr>
               <a:spcBef>
-                <a:spcPts val="200"/>
-              </a:spcBef>
-              <a:spcAft>
-                <a:spcPts val="500"/>
-              </a:spcAft>
-            </a:pPr>
-            <a:r>
-              <a:rPr sz="1800">
+                <a:spcPts val="100"/>
+              </a:spcBef>
+              <a:spcAft>
+                <a:spcPts val="400"/>
+              </a:spcAft>
+            </a:pPr>
+            <a:r>
+              <a:rPr sz="1600">
                 <a:solidFill>
                   <a:srgbClr val="0F172A"/>
                 </a:solidFill>
@@ -4867,14 +6735,14 @@
           <a:p>
             <a:pPr>
               <a:spcBef>
-                <a:spcPts val="200"/>
-              </a:spcBef>
-              <a:spcAft>
-                <a:spcPts val="500"/>
-              </a:spcAft>
-            </a:pPr>
-            <a:r>
-              <a:rPr sz="1800">
+                <a:spcPts val="100"/>
+              </a:spcBef>
+              <a:spcAft>
+                <a:spcPts val="400"/>
+              </a:spcAft>
+            </a:pPr>
+            <a:r>
+              <a:rPr sz="1600">
                 <a:solidFill>
                   <a:srgbClr val="0F172A"/>
                 </a:solidFill>
@@ -4886,14 +6754,14 @@
           <a:p>
             <a:pPr>
               <a:spcBef>
-                <a:spcPts val="200"/>
-              </a:spcBef>
-              <a:spcAft>
-                <a:spcPts val="500"/>
-              </a:spcAft>
-            </a:pPr>
-            <a:r>
-              <a:rPr sz="1800">
+                <a:spcPts val="100"/>
+              </a:spcBef>
+              <a:spcAft>
+                <a:spcPts val="400"/>
+              </a:spcAft>
+            </a:pPr>
+            <a:r>
+              <a:rPr sz="1600">
                 <a:solidFill>
                   <a:srgbClr val="0F172A"/>
                 </a:solidFill>
@@ -4905,14 +6773,14 @@
           <a:p>
             <a:pPr>
               <a:spcBef>
-                <a:spcPts val="200"/>
-              </a:spcBef>
-              <a:spcAft>
-                <a:spcPts val="500"/>
-              </a:spcAft>
-            </a:pPr>
-            <a:r>
-              <a:rPr sz="1800">
+                <a:spcPts val="100"/>
+              </a:spcBef>
+              <a:spcAft>
+                <a:spcPts val="400"/>
+              </a:spcAft>
+            </a:pPr>
+            <a:r>
+              <a:rPr sz="1600">
                 <a:solidFill>
                   <a:srgbClr val="0F172A"/>
                 </a:solidFill>
@@ -4924,14 +6792,14 @@
           <a:p>
             <a:pPr>
               <a:spcBef>
-                <a:spcPts val="200"/>
-              </a:spcBef>
-              <a:spcAft>
-                <a:spcPts val="500"/>
-              </a:spcAft>
-            </a:pPr>
-            <a:r>
-              <a:rPr sz="1800">
+                <a:spcPts val="100"/>
+              </a:spcBef>
+              <a:spcAft>
+                <a:spcPts val="400"/>
+              </a:spcAft>
+            </a:pPr>
+            <a:r>
+              <a:rPr sz="1600">
                 <a:solidFill>
                   <a:srgbClr val="0F172A"/>
                 </a:solidFill>
@@ -4943,14 +6811,14 @@
           <a:p>
             <a:pPr>
               <a:spcBef>
-                <a:spcPts val="200"/>
-              </a:spcBef>
-              <a:spcAft>
-                <a:spcPts val="500"/>
-              </a:spcAft>
-            </a:pPr>
-            <a:r>
-              <a:rPr sz="1800">
+                <a:spcPts val="100"/>
+              </a:spcBef>
+              <a:spcAft>
+                <a:spcPts val="400"/>
+              </a:spcAft>
+            </a:pPr>
+            <a:r>
+              <a:rPr sz="1600">
                 <a:solidFill>
                   <a:srgbClr val="0F172A"/>
                 </a:solidFill>
@@ -4962,14 +6830,14 @@
           <a:p>
             <a:pPr>
               <a:spcBef>
-                <a:spcPts val="200"/>
-              </a:spcBef>
-              <a:spcAft>
-                <a:spcPts val="500"/>
-              </a:spcAft>
-            </a:pPr>
-            <a:r>
-              <a:rPr sz="1800">
+                <a:spcPts val="100"/>
+              </a:spcBef>
+              <a:spcAft>
+                <a:spcPts val="400"/>
+              </a:spcAft>
+            </a:pPr>
+            <a:r>
+              <a:rPr sz="1600">
                 <a:solidFill>
                   <a:srgbClr val="0F172A"/>
                 </a:solidFill>
@@ -4981,14 +6849,14 @@
           <a:p>
             <a:pPr>
               <a:spcBef>
-                <a:spcPts val="200"/>
-              </a:spcBef>
-              <a:spcAft>
-                <a:spcPts val="500"/>
-              </a:spcAft>
-            </a:pPr>
-            <a:r>
-              <a:rPr sz="1800">
+                <a:spcPts val="100"/>
+              </a:spcBef>
+              <a:spcAft>
+                <a:spcPts val="400"/>
+              </a:spcAft>
+            </a:pPr>
+            <a:r>
+              <a:rPr sz="1600">
                 <a:solidFill>
                   <a:srgbClr val="0F172A"/>
                 </a:solidFill>
@@ -5000,14 +6868,14 @@
           <a:p>
             <a:pPr>
               <a:spcBef>
-                <a:spcPts val="200"/>
-              </a:spcBef>
-              <a:spcAft>
-                <a:spcPts val="500"/>
-              </a:spcAft>
-            </a:pPr>
-            <a:r>
-              <a:rPr sz="1800">
+                <a:spcPts val="100"/>
+              </a:spcBef>
+              <a:spcAft>
+                <a:spcPts val="400"/>
+              </a:spcAft>
+            </a:pPr>
+            <a:r>
+              <a:rPr sz="1600">
                 <a:solidFill>
                   <a:srgbClr val="0F172A"/>
                 </a:solidFill>
@@ -5019,14 +6887,14 @@
           <a:p>
             <a:pPr>
               <a:spcBef>
-                <a:spcPts val="200"/>
-              </a:spcBef>
-              <a:spcAft>
-                <a:spcPts val="500"/>
-              </a:spcAft>
-            </a:pPr>
-            <a:r>
-              <a:rPr sz="1800">
+                <a:spcPts val="100"/>
+              </a:spcBef>
+              <a:spcAft>
+                <a:spcPts val="400"/>
+              </a:spcAft>
+            </a:pPr>
+            <a:r>
+              <a:rPr sz="1600">
                 <a:solidFill>
                   <a:srgbClr val="0F172A"/>
                 </a:solidFill>
@@ -5038,14 +6906,14 @@
           <a:p>
             <a:pPr>
               <a:spcBef>
-                <a:spcPts val="200"/>
-              </a:spcBef>
-              <a:spcAft>
-                <a:spcPts val="500"/>
-              </a:spcAft>
-            </a:pPr>
-            <a:r>
-              <a:rPr sz="1800">
+                <a:spcPts val="100"/>
+              </a:spcBef>
+              <a:spcAft>
+                <a:spcPts val="400"/>
+              </a:spcAft>
+            </a:pPr>
+            <a:r>
+              <a:rPr sz="1600">
                 <a:solidFill>
                   <a:srgbClr val="0F172A"/>
                 </a:solidFill>
@@ -5057,14 +6925,14 @@
           <a:p>
             <a:pPr>
               <a:spcBef>
-                <a:spcPts val="200"/>
-              </a:spcBef>
-              <a:spcAft>
-                <a:spcPts val="500"/>
-              </a:spcAft>
-            </a:pPr>
-            <a:r>
-              <a:rPr sz="1800">
+                <a:spcPts val="100"/>
+              </a:spcBef>
+              <a:spcAft>
+                <a:spcPts val="400"/>
+              </a:spcAft>
+            </a:pPr>
+            <a:r>
+              <a:rPr sz="1600">
                 <a:solidFill>
                   <a:srgbClr val="0F172A"/>
                 </a:solidFill>
@@ -5076,20 +6944,153 @@
           <a:p>
             <a:pPr>
               <a:spcBef>
-                <a:spcPts val="200"/>
-              </a:spcBef>
-              <a:spcAft>
-                <a:spcPts val="500"/>
-              </a:spcAft>
-            </a:pPr>
-            <a:r>
-              <a:rPr sz="1800">
+                <a:spcPts val="100"/>
+              </a:spcBef>
+              <a:spcAft>
+                <a:spcPts val="400"/>
+              </a:spcAft>
+            </a:pPr>
+            <a:r>
+              <a:rPr sz="1600">
                 <a:solidFill>
                   <a:srgbClr val="0F172A"/>
                 </a:solidFill>
                 <a:latin typeface="Microsoft YaHei"/>
               </a:rPr>
               <a:t>[R8] ETSI, TS 103 097 / TS 102 941 / TS 103 759（标准下载链接见 R2 / R3）</a:t>
+            </a:r>
+          </a:p>
+          <a:p>
+            <a:pPr>
+              <a:spcBef>
+                <a:spcPts val="100"/>
+              </a:spcBef>
+              <a:spcAft>
+                <a:spcPts val="400"/>
+              </a:spcAft>
+            </a:pPr>
+            <a:r>
+              <a:rPr sz="1600">
+                <a:solidFill>
+                  <a:srgbClr val="0F172A"/>
+                </a:solidFill>
+                <a:latin typeface="Microsoft YaHei"/>
+              </a:rPr>
+              <a:t>[R9] B. Brecht et al., A Security Credential Management System for V2X Communications, IEEE Transactions on Intelligent Transportation Systems, 2018（引文与入口见 R13）</a:t>
+            </a:r>
+          </a:p>
+          <a:p>
+            <a:pPr>
+              <a:spcBef>
+                <a:spcPts val="100"/>
+              </a:spcBef>
+              <a:spcAft>
+                <a:spcPts val="400"/>
+              </a:spcAft>
+            </a:pPr>
+            <a:r>
+              <a:rPr sz="1600">
+                <a:solidFill>
+                  <a:srgbClr val="0F172A"/>
+                </a:solidFill>
+                <a:latin typeface="Microsoft YaHei"/>
+              </a:rPr>
+              <a:t>[R10] Z. Amjad et al., Low Latency V2X Applications and Network Requirements: Performance Evaluation, IEEE Intelligent Vehicles Symposium, 2018（引文与入口见 R13）</a:t>
+            </a:r>
+          </a:p>
+          <a:p>
+            <a:pPr>
+              <a:spcBef>
+                <a:spcPts val="100"/>
+              </a:spcBef>
+              <a:spcAft>
+                <a:spcPts val="400"/>
+              </a:spcAft>
+            </a:pPr>
+            <a:r>
+              <a:rPr sz="1600">
+                <a:solidFill>
+                  <a:srgbClr val="0F172A"/>
+                </a:solidFill>
+                <a:latin typeface="Microsoft YaHei"/>
+              </a:rPr>
+              <a:t>[R11] A. C. H. Chen et al., Implementation and Performance Analysis of Security Credential Management System Based on IEEE 1609.2 and 1609.2.1 Standards, IEEE ICMLANT, 2023（引文与入口见 R13）</a:t>
+            </a:r>
+          </a:p>
+          <a:p>
+            <a:pPr>
+              <a:spcBef>
+                <a:spcPts val="100"/>
+              </a:spcBef>
+              <a:spcAft>
+                <a:spcPts val="400"/>
+              </a:spcAft>
+            </a:pPr>
+            <a:r>
+              <a:rPr sz="1600">
+                <a:solidFill>
+                  <a:srgbClr val="0F172A"/>
+                </a:solidFill>
+                <a:latin typeface="Microsoft YaHei"/>
+              </a:rPr>
+              <a:t>[R12] Mattyilmago, SecureRoads_PKI README</a:t>
+            </a:r>
+          </a:p>
+          <a:p>
+            <a:pPr>
+              <a:spcBef>
+                <a:spcPts val="100"/>
+              </a:spcBef>
+              <a:spcAft>
+                <a:spcPts val="400"/>
+              </a:spcAft>
+            </a:pPr>
+            <a:r>
+              <a:rPr sz="1600">
+                <a:solidFill>
+                  <a:srgbClr val="0F172A"/>
+                </a:solidFill>
+                <a:latin typeface="Microsoft YaHei"/>
+              </a:rPr>
+              <a:t>https://github.com/Mattyilmago/SecureRoads_PKI/blob/e2dd5b533cbfdbde5a0723d8b54b3d22d600fa49/README.md</a:t>
+            </a:r>
+          </a:p>
+          <a:p>
+            <a:pPr>
+              <a:spcBef>
+                <a:spcPts val="100"/>
+              </a:spcBef>
+              <a:spcAft>
+                <a:spcPts val="400"/>
+              </a:spcAft>
+            </a:pPr>
+            <a:r>
+              <a:rPr sz="1600">
+                <a:solidFill>
+                  <a:srgbClr val="0F172A"/>
+                </a:solidFill>
+                <a:latin typeface="Microsoft YaHei"/>
+              </a:rPr>
+              <a:t>[R13] Jelloge, Evaluating Cloud-Hosted SCMS Performance for C-V2X Using a QNX RTOS Client</a:t>
+            </a:r>
+          </a:p>
+          <a:p>
+            <a:pPr>
+              <a:spcBef>
+                <a:spcPts val="100"/>
+              </a:spcBef>
+              <a:spcAft>
+                <a:spcPts val="400"/>
+              </a:spcAft>
+            </a:pPr>
+            <a:r>
+              <a:rPr sz="1600">
+                <a:solidFill>
+                  <a:srgbClr val="0F172A"/>
+                </a:solidFill>
+                <a:latin typeface="Microsoft YaHei"/>
+              </a:rPr>
+              <a:t>https://github.com/Jelloge/scms-v2x-cloud/blob/3190ea8bf309dfa9d76bc1382fc50414c963f638/README.md</a:t>
             </a:r>
           </a:p>
         </p:txBody>
@@ -5102,8 +7103,8 @@
         </p:nvSpPr>
         <p:spPr>
           <a:xfrm>
-            <a:off x="594360" y="6263640"/>
-            <a:ext cx="10972800" cy="274320"/>
+            <a:off x="594360" y="6236208"/>
+            <a:ext cx="10972800" cy="228600"/>
           </a:xfrm>
           <a:prstGeom prst="rect">
             <a:avLst/>
@@ -5124,7 +7125,7 @@
                 </a:solidFill>
                 <a:latin typeface="Microsoft YaHei"/>
               </a:rPr>
-              <a:t>参考：[R1][R2][R3][R4][R5][R6][R7][R8]</a:t>
+              <a:t>参考：[R10][R11][R12][R13][R1][R2][R3][R4][R5][R6][R7][R8][R9]</a:t>
             </a:r>
           </a:p>
         </p:txBody>
@@ -5243,7 +7244,7 @@
         <p:spPr>
           <a:xfrm>
             <a:off x="502920" y="109728"/>
-            <a:ext cx="10789920" cy="365760"/>
+            <a:ext cx="10972800" cy="365760"/>
           </a:xfrm>
           <a:prstGeom prst="rect">
             <a:avLst/>
@@ -5277,7 +7278,7 @@
         <p:spPr>
           <a:xfrm>
             <a:off x="685800" y="1234440"/>
-            <a:ext cx="10972800" cy="4754880"/>
+            <a:ext cx="10972800" cy="4846320"/>
           </a:xfrm>
           <a:prstGeom prst="rect">
             <a:avLst/>
@@ -5292,10 +7293,10 @@
           <a:p>
             <a:pPr>
               <a:spcBef>
-                <a:spcPts val="200"/>
-              </a:spcBef>
-              <a:spcAft>
-                <a:spcPts val="500"/>
+                <a:spcPts val="100"/>
+              </a:spcBef>
+              <a:spcAft>
+                <a:spcPts val="400"/>
               </a:spcAft>
             </a:pPr>
             <a:r>
@@ -5311,10 +7312,10 @@
           <a:p>
             <a:pPr>
               <a:spcBef>
-                <a:spcPts val="200"/>
-              </a:spcBef>
-              <a:spcAft>
-                <a:spcPts val="500"/>
+                <a:spcPts val="100"/>
+              </a:spcBef>
+              <a:spcAft>
+                <a:spcPts val="400"/>
               </a:spcAft>
             </a:pPr>
             <a:r>
@@ -5330,10 +7331,10 @@
           <a:p>
             <a:pPr>
               <a:spcBef>
-                <a:spcPts val="200"/>
-              </a:spcBef>
-              <a:spcAft>
-                <a:spcPts val="500"/>
+                <a:spcPts val="100"/>
+              </a:spcBef>
+              <a:spcAft>
+                <a:spcPts val="400"/>
               </a:spcAft>
             </a:pPr>
             <a:r>
@@ -5349,10 +7350,10 @@
           <a:p>
             <a:pPr>
               <a:spcBef>
-                <a:spcPts val="200"/>
-              </a:spcBef>
-              <a:spcAft>
-                <a:spcPts val="500"/>
+                <a:spcPts val="100"/>
+              </a:spcBef>
+              <a:spcAft>
+                <a:spcPts val="400"/>
               </a:spcAft>
             </a:pPr>
             <a:r>
@@ -5368,10 +7369,10 @@
           <a:p>
             <a:pPr>
               <a:spcBef>
-                <a:spcPts val="200"/>
-              </a:spcBef>
-              <a:spcAft>
-                <a:spcPts val="500"/>
+                <a:spcPts val="100"/>
+              </a:spcBef>
+              <a:spcAft>
+                <a:spcPts val="400"/>
               </a:spcAft>
             </a:pPr>
             <a:r>
@@ -5394,8 +7395,8 @@
         </p:nvSpPr>
         <p:spPr>
           <a:xfrm>
-            <a:off x="594360" y="6263640"/>
-            <a:ext cx="10972800" cy="274320"/>
+            <a:off x="594360" y="6236208"/>
+            <a:ext cx="10972800" cy="228600"/>
           </a:xfrm>
           <a:prstGeom prst="rect">
             <a:avLst/>
@@ -5535,7 +7536,7 @@
         <p:spPr>
           <a:xfrm>
             <a:off x="502920" y="109728"/>
-            <a:ext cx="10789920" cy="365760"/>
+            <a:ext cx="10972800" cy="365760"/>
           </a:xfrm>
           <a:prstGeom prst="rect">
             <a:avLst/>
@@ -5569,7 +7570,7 @@
         <p:spPr>
           <a:xfrm>
             <a:off x="685800" y="1234440"/>
-            <a:ext cx="10972800" cy="4754880"/>
+            <a:ext cx="10972800" cy="4846320"/>
           </a:xfrm>
           <a:prstGeom prst="rect">
             <a:avLst/>
@@ -5584,10 +7585,10 @@
           <a:p>
             <a:pPr>
               <a:spcBef>
-                <a:spcPts val="200"/>
-              </a:spcBef>
-              <a:spcAft>
-                <a:spcPts val="500"/>
+                <a:spcPts val="100"/>
+              </a:spcBef>
+              <a:spcAft>
+                <a:spcPts val="400"/>
               </a:spcAft>
             </a:pPr>
             <a:r>
@@ -5603,10 +7604,10 @@
           <a:p>
             <a:pPr>
               <a:spcBef>
-                <a:spcPts val="200"/>
-              </a:spcBef>
-              <a:spcAft>
-                <a:spcPts val="500"/>
+                <a:spcPts val="100"/>
+              </a:spcBef>
+              <a:spcAft>
+                <a:spcPts val="400"/>
               </a:spcAft>
             </a:pPr>
             <a:r>
@@ -5622,10 +7623,10 @@
           <a:p>
             <a:pPr lvl="1">
               <a:spcBef>
-                <a:spcPts val="200"/>
-              </a:spcBef>
-              <a:spcAft>
-                <a:spcPts val="500"/>
+                <a:spcPts val="100"/>
+              </a:spcBef>
+              <a:spcAft>
+                <a:spcPts val="400"/>
               </a:spcAft>
             </a:pPr>
             <a:r>
@@ -5641,10 +7642,10 @@
           <a:p>
             <a:pPr lvl="1">
               <a:spcBef>
-                <a:spcPts val="200"/>
-              </a:spcBef>
-              <a:spcAft>
-                <a:spcPts val="500"/>
+                <a:spcPts val="100"/>
+              </a:spcBef>
+              <a:spcAft>
+                <a:spcPts val="400"/>
               </a:spcAft>
             </a:pPr>
             <a:r>
@@ -5660,10 +7661,10 @@
           <a:p>
             <a:pPr lvl="1">
               <a:spcBef>
-                <a:spcPts val="200"/>
-              </a:spcBef>
-              <a:spcAft>
-                <a:spcPts val="500"/>
+                <a:spcPts val="100"/>
+              </a:spcBef>
+              <a:spcAft>
+                <a:spcPts val="400"/>
               </a:spcAft>
             </a:pPr>
             <a:r>
@@ -5679,10 +7680,10 @@
           <a:p>
             <a:pPr lvl="1">
               <a:spcBef>
-                <a:spcPts val="200"/>
-              </a:spcBef>
-              <a:spcAft>
-                <a:spcPts val="500"/>
+                <a:spcPts val="100"/>
+              </a:spcBef>
+              <a:spcAft>
+                <a:spcPts val="400"/>
               </a:spcAft>
             </a:pPr>
             <a:r>
@@ -5698,10 +7699,10 @@
           <a:p>
             <a:pPr>
               <a:spcBef>
-                <a:spcPts val="200"/>
-              </a:spcBef>
-              <a:spcAft>
-                <a:spcPts val="500"/>
+                <a:spcPts val="100"/>
+              </a:spcBef>
+              <a:spcAft>
+                <a:spcPts val="400"/>
               </a:spcAft>
             </a:pPr>
             <a:r>
@@ -5724,8 +7725,8 @@
         </p:nvSpPr>
         <p:spPr>
           <a:xfrm>
-            <a:off x="594360" y="6263640"/>
-            <a:ext cx="10972800" cy="274320"/>
+            <a:off x="594360" y="6236208"/>
+            <a:ext cx="10972800" cy="228600"/>
           </a:xfrm>
           <a:prstGeom prst="rect">
             <a:avLst/>
@@ -5865,7 +7866,7 @@
         <p:spPr>
           <a:xfrm>
             <a:off x="502920" y="109728"/>
-            <a:ext cx="10789920" cy="365760"/>
+            <a:ext cx="10972800" cy="365760"/>
           </a:xfrm>
           <a:prstGeom prst="rect">
             <a:avLst/>
@@ -5899,7 +7900,7 @@
         <p:spPr>
           <a:xfrm>
             <a:off x="685800" y="1234440"/>
-            <a:ext cx="10972800" cy="4754880"/>
+            <a:ext cx="10972800" cy="4846320"/>
           </a:xfrm>
           <a:prstGeom prst="rect">
             <a:avLst/>
@@ -5914,10 +7915,10 @@
           <a:p>
             <a:pPr>
               <a:spcBef>
-                <a:spcPts val="200"/>
-              </a:spcBef>
-              <a:spcAft>
-                <a:spcPts val="500"/>
+                <a:spcPts val="100"/>
+              </a:spcBef>
+              <a:spcAft>
+                <a:spcPts val="400"/>
               </a:spcAft>
             </a:pPr>
             <a:r>
@@ -5933,10 +7934,10 @@
           <a:p>
             <a:pPr>
               <a:spcBef>
-                <a:spcPts val="200"/>
-              </a:spcBef>
-              <a:spcAft>
-                <a:spcPts val="500"/>
+                <a:spcPts val="100"/>
+              </a:spcBef>
+              <a:spcAft>
+                <a:spcPts val="400"/>
               </a:spcAft>
             </a:pPr>
             <a:r>
@@ -5952,10 +7953,10 @@
           <a:p>
             <a:pPr>
               <a:spcBef>
-                <a:spcPts val="200"/>
-              </a:spcBef>
-              <a:spcAft>
-                <a:spcPts val="500"/>
+                <a:spcPts val="100"/>
+              </a:spcBef>
+              <a:spcAft>
+                <a:spcPts val="400"/>
               </a:spcAft>
             </a:pPr>
             <a:r>
@@ -5971,10 +7972,10 @@
           <a:p>
             <a:pPr>
               <a:spcBef>
-                <a:spcPts val="200"/>
-              </a:spcBef>
-              <a:spcAft>
-                <a:spcPts val="500"/>
+                <a:spcPts val="100"/>
+              </a:spcBef>
+              <a:spcAft>
+                <a:spcPts val="400"/>
               </a:spcAft>
             </a:pPr>
             <a:r>
@@ -5990,10 +7991,10 @@
           <a:p>
             <a:pPr>
               <a:spcBef>
-                <a:spcPts val="200"/>
-              </a:spcBef>
-              <a:spcAft>
-                <a:spcPts val="500"/>
+                <a:spcPts val="100"/>
+              </a:spcBef>
+              <a:spcAft>
+                <a:spcPts val="400"/>
               </a:spcAft>
             </a:pPr>
             <a:r>
@@ -6016,8 +8017,8 @@
         </p:nvSpPr>
         <p:spPr>
           <a:xfrm>
-            <a:off x="594360" y="6263640"/>
-            <a:ext cx="10972800" cy="274320"/>
+            <a:off x="594360" y="6236208"/>
+            <a:ext cx="10972800" cy="228600"/>
           </a:xfrm>
           <a:prstGeom prst="rect">
             <a:avLst/>
@@ -6157,7 +8158,7 @@
         <p:spPr>
           <a:xfrm>
             <a:off x="502920" y="109728"/>
-            <a:ext cx="10789920" cy="365760"/>
+            <a:ext cx="10972800" cy="365760"/>
           </a:xfrm>
           <a:prstGeom prst="rect">
             <a:avLst/>
@@ -7989,7 +9990,7 @@
         <p:spPr>
           <a:xfrm>
             <a:off x="502920" y="109728"/>
-            <a:ext cx="10789920" cy="365760"/>
+            <a:ext cx="10972800" cy="365760"/>
           </a:xfrm>
           <a:prstGeom prst="rect">
             <a:avLst/>
@@ -8023,7 +10024,7 @@
         <p:spPr>
           <a:xfrm>
             <a:off x="685800" y="1234440"/>
-            <a:ext cx="10972800" cy="4754880"/>
+            <a:ext cx="10972800" cy="4846320"/>
           </a:xfrm>
           <a:prstGeom prst="rect">
             <a:avLst/>
@@ -8038,10 +10039,10 @@
           <a:p>
             <a:pPr>
               <a:spcBef>
-                <a:spcPts val="200"/>
-              </a:spcBef>
-              <a:spcAft>
-                <a:spcPts val="500"/>
+                <a:spcPts val="100"/>
+              </a:spcBef>
+              <a:spcAft>
+                <a:spcPts val="400"/>
               </a:spcAft>
             </a:pPr>
             <a:r>
@@ -8057,10 +10058,10 @@
           <a:p>
             <a:pPr>
               <a:spcBef>
-                <a:spcPts val="200"/>
-              </a:spcBef>
-              <a:spcAft>
-                <a:spcPts val="500"/>
+                <a:spcPts val="100"/>
+              </a:spcBef>
+              <a:spcAft>
+                <a:spcPts val="400"/>
               </a:spcAft>
             </a:pPr>
             <a:r>
@@ -8076,10 +10077,10 @@
           <a:p>
             <a:pPr>
               <a:spcBef>
-                <a:spcPts val="200"/>
-              </a:spcBef>
-              <a:spcAft>
-                <a:spcPts val="500"/>
+                <a:spcPts val="100"/>
+              </a:spcBef>
+              <a:spcAft>
+                <a:spcPts val="400"/>
               </a:spcAft>
             </a:pPr>
             <a:r>
@@ -8095,10 +10096,10 @@
           <a:p>
             <a:pPr>
               <a:spcBef>
-                <a:spcPts val="200"/>
-              </a:spcBef>
-              <a:spcAft>
-                <a:spcPts val="500"/>
+                <a:spcPts val="100"/>
+              </a:spcBef>
+              <a:spcAft>
+                <a:spcPts val="400"/>
               </a:spcAft>
             </a:pPr>
             <a:r>
@@ -8114,10 +10115,10 @@
           <a:p>
             <a:pPr>
               <a:spcBef>
-                <a:spcPts val="200"/>
-              </a:spcBef>
-              <a:spcAft>
-                <a:spcPts val="500"/>
+                <a:spcPts val="100"/>
+              </a:spcBef>
+              <a:spcAft>
+                <a:spcPts val="400"/>
               </a:spcAft>
             </a:pPr>
             <a:r>
@@ -8133,10 +10134,10 @@
           <a:p>
             <a:pPr>
               <a:spcBef>
-                <a:spcPts val="200"/>
-              </a:spcBef>
-              <a:spcAft>
-                <a:spcPts val="500"/>
+                <a:spcPts val="100"/>
+              </a:spcBef>
+              <a:spcAft>
+                <a:spcPts val="400"/>
               </a:spcAft>
             </a:pPr>
             <a:r>
@@ -8152,10 +10153,10 @@
           <a:p>
             <a:pPr>
               <a:spcBef>
-                <a:spcPts val="200"/>
-              </a:spcBef>
-              <a:spcAft>
-                <a:spcPts val="500"/>
+                <a:spcPts val="100"/>
+              </a:spcBef>
+              <a:spcAft>
+                <a:spcPts val="400"/>
               </a:spcAft>
             </a:pPr>
             <a:r>
@@ -8171,10 +10172,10 @@
           <a:p>
             <a:pPr>
               <a:spcBef>
-                <a:spcPts val="200"/>
-              </a:spcBef>
-              <a:spcAft>
-                <a:spcPts val="500"/>
+                <a:spcPts val="100"/>
+              </a:spcBef>
+              <a:spcAft>
+                <a:spcPts val="400"/>
               </a:spcAft>
             </a:pPr>
             <a:r>
@@ -8190,10 +10191,10 @@
           <a:p>
             <a:pPr lvl="1">
               <a:spcBef>
-                <a:spcPts val="200"/>
-              </a:spcBef>
-              <a:spcAft>
-                <a:spcPts val="500"/>
+                <a:spcPts val="100"/>
+              </a:spcBef>
+              <a:spcAft>
+                <a:spcPts val="400"/>
               </a:spcAft>
             </a:pPr>
             <a:r>
@@ -8209,10 +10210,10 @@
           <a:p>
             <a:pPr lvl="1">
               <a:spcBef>
-                <a:spcPts val="200"/>
-              </a:spcBef>
-              <a:spcAft>
-                <a:spcPts val="500"/>
+                <a:spcPts val="100"/>
+              </a:spcBef>
+              <a:spcAft>
+                <a:spcPts val="400"/>
               </a:spcAft>
             </a:pPr>
             <a:r>
@@ -8228,10 +10229,10 @@
           <a:p>
             <a:pPr lvl="1">
               <a:spcBef>
-                <a:spcPts val="200"/>
-              </a:spcBef>
-              <a:spcAft>
-                <a:spcPts val="500"/>
+                <a:spcPts val="100"/>
+              </a:spcBef>
+              <a:spcAft>
+                <a:spcPts val="400"/>
               </a:spcAft>
             </a:pPr>
             <a:r>
@@ -8247,10 +10248,10 @@
           <a:p>
             <a:pPr>
               <a:spcBef>
-                <a:spcPts val="200"/>
-              </a:spcBef>
-              <a:spcAft>
-                <a:spcPts val="500"/>
+                <a:spcPts val="100"/>
+              </a:spcBef>
+              <a:spcAft>
+                <a:spcPts val="400"/>
               </a:spcAft>
             </a:pPr>
             <a:r>
@@ -8273,8 +10274,8 @@
         </p:nvSpPr>
         <p:spPr>
           <a:xfrm>
-            <a:off x="594360" y="6263640"/>
-            <a:ext cx="10972800" cy="274320"/>
+            <a:off x="594360" y="6236208"/>
+            <a:ext cx="10972800" cy="228600"/>
           </a:xfrm>
           <a:prstGeom prst="rect">
             <a:avLst/>
@@ -8414,7 +10415,7 @@
         <p:spPr>
           <a:xfrm>
             <a:off x="502920" y="109728"/>
-            <a:ext cx="10789920" cy="365760"/>
+            <a:ext cx="10972800" cy="365760"/>
           </a:xfrm>
           <a:prstGeom prst="rect">
             <a:avLst/>
@@ -8448,7 +10449,7 @@
         <p:spPr>
           <a:xfrm>
             <a:off x="685800" y="1234440"/>
-            <a:ext cx="10972800" cy="4754880"/>
+            <a:ext cx="10972800" cy="4846320"/>
           </a:xfrm>
           <a:prstGeom prst="rect">
             <a:avLst/>
@@ -8463,10 +10464,10 @@
           <a:p>
             <a:pPr>
               <a:spcBef>
-                <a:spcPts val="200"/>
-              </a:spcBef>
-              <a:spcAft>
-                <a:spcPts val="500"/>
+                <a:spcPts val="100"/>
+              </a:spcBef>
+              <a:spcAft>
+                <a:spcPts val="400"/>
               </a:spcAft>
             </a:pPr>
             <a:r>
@@ -8482,10 +10483,10 @@
           <a:p>
             <a:pPr>
               <a:spcBef>
-                <a:spcPts val="200"/>
-              </a:spcBef>
-              <a:spcAft>
-                <a:spcPts val="500"/>
+                <a:spcPts val="100"/>
+              </a:spcBef>
+              <a:spcAft>
+                <a:spcPts val="400"/>
               </a:spcAft>
             </a:pPr>
             <a:r>
@@ -8501,10 +10502,10 @@
           <a:p>
             <a:pPr>
               <a:spcBef>
-                <a:spcPts val="200"/>
-              </a:spcBef>
-              <a:spcAft>
-                <a:spcPts val="500"/>
+                <a:spcPts val="100"/>
+              </a:spcBef>
+              <a:spcAft>
+                <a:spcPts val="400"/>
               </a:spcAft>
             </a:pPr>
             <a:r>
@@ -8520,10 +10521,10 @@
           <a:p>
             <a:pPr>
               <a:spcBef>
-                <a:spcPts val="200"/>
-              </a:spcBef>
-              <a:spcAft>
-                <a:spcPts val="500"/>
+                <a:spcPts val="100"/>
+              </a:spcBef>
+              <a:spcAft>
+                <a:spcPts val="400"/>
               </a:spcAft>
             </a:pPr>
             <a:r>
@@ -8539,10 +10540,10 @@
           <a:p>
             <a:pPr>
               <a:spcBef>
-                <a:spcPts val="200"/>
-              </a:spcBef>
-              <a:spcAft>
-                <a:spcPts val="500"/>
+                <a:spcPts val="100"/>
+              </a:spcBef>
+              <a:spcAft>
+                <a:spcPts val="400"/>
               </a:spcAft>
             </a:pPr>
             <a:r>
@@ -8558,10 +10559,10 @@
           <a:p>
             <a:pPr>
               <a:spcBef>
-                <a:spcPts val="200"/>
-              </a:spcBef>
-              <a:spcAft>
-                <a:spcPts val="500"/>
+                <a:spcPts val="100"/>
+              </a:spcBef>
+              <a:spcAft>
+                <a:spcPts val="400"/>
               </a:spcAft>
             </a:pPr>
             <a:r>
@@ -8577,10 +10578,10 @@
           <a:p>
             <a:pPr>
               <a:spcBef>
-                <a:spcPts val="200"/>
-              </a:spcBef>
-              <a:spcAft>
-                <a:spcPts val="500"/>
+                <a:spcPts val="100"/>
+              </a:spcBef>
+              <a:spcAft>
+                <a:spcPts val="400"/>
               </a:spcAft>
             </a:pPr>
             <a:r>
@@ -8596,10 +10597,10 @@
           <a:p>
             <a:pPr>
               <a:spcBef>
-                <a:spcPts val="200"/>
-              </a:spcBef>
-              <a:spcAft>
-                <a:spcPts val="500"/>
+                <a:spcPts val="100"/>
+              </a:spcBef>
+              <a:spcAft>
+                <a:spcPts val="400"/>
               </a:spcAft>
             </a:pPr>
             <a:r>
@@ -8615,10 +10616,10 @@
           <a:p>
             <a:pPr>
               <a:spcBef>
-                <a:spcPts val="200"/>
-              </a:spcBef>
-              <a:spcAft>
-                <a:spcPts val="500"/>
+                <a:spcPts val="100"/>
+              </a:spcBef>
+              <a:spcAft>
+                <a:spcPts val="400"/>
               </a:spcAft>
             </a:pPr>
             <a:r>
@@ -8634,10 +10635,10 @@
           <a:p>
             <a:pPr>
               <a:spcBef>
-                <a:spcPts val="200"/>
-              </a:spcBef>
-              <a:spcAft>
-                <a:spcPts val="500"/>
+                <a:spcPts val="100"/>
+              </a:spcBef>
+              <a:spcAft>
+                <a:spcPts val="400"/>
               </a:spcAft>
             </a:pPr>
             <a:r>
@@ -8653,10 +10654,10 @@
           <a:p>
             <a:pPr>
               <a:spcBef>
-                <a:spcPts val="200"/>
-              </a:spcBef>
-              <a:spcAft>
-                <a:spcPts val="500"/>
+                <a:spcPts val="100"/>
+              </a:spcBef>
+              <a:spcAft>
+                <a:spcPts val="400"/>
               </a:spcAft>
             </a:pPr>
             <a:r>
@@ -8672,10 +10673,10 @@
           <a:p>
             <a:pPr>
               <a:spcBef>
-                <a:spcPts val="200"/>
-              </a:spcBef>
-              <a:spcAft>
-                <a:spcPts val="500"/>
+                <a:spcPts val="100"/>
+              </a:spcBef>
+              <a:spcAft>
+                <a:spcPts val="400"/>
               </a:spcAft>
             </a:pPr>
             <a:r>
@@ -8698,8 +10699,8 @@
         </p:nvSpPr>
         <p:spPr>
           <a:xfrm>
-            <a:off x="594360" y="6263640"/>
-            <a:ext cx="10972800" cy="274320"/>
+            <a:off x="594360" y="6236208"/>
+            <a:ext cx="10972800" cy="228600"/>
           </a:xfrm>
           <a:prstGeom prst="rect">
             <a:avLst/>
@@ -8839,7 +10840,7 @@
         <p:spPr>
           <a:xfrm>
             <a:off x="502920" y="109728"/>
-            <a:ext cx="10789920" cy="365760"/>
+            <a:ext cx="10972800" cy="365760"/>
           </a:xfrm>
           <a:prstGeom prst="rect">
             <a:avLst/>
@@ -8873,7 +10874,7 @@
         <p:spPr>
           <a:xfrm>
             <a:off x="685800" y="1234440"/>
-            <a:ext cx="10972800" cy="4754880"/>
+            <a:ext cx="10972800" cy="4846320"/>
           </a:xfrm>
           <a:prstGeom prst="rect">
             <a:avLst/>
@@ -8888,10 +10889,10 @@
           <a:p>
             <a:pPr>
               <a:spcBef>
-                <a:spcPts val="200"/>
-              </a:spcBef>
-              <a:spcAft>
-                <a:spcPts val="500"/>
+                <a:spcPts val="100"/>
+              </a:spcBef>
+              <a:spcAft>
+                <a:spcPts val="400"/>
               </a:spcAft>
             </a:pPr>
             <a:r>
@@ -8907,10 +10908,10 @@
           <a:p>
             <a:pPr>
               <a:spcBef>
-                <a:spcPts val="200"/>
-              </a:spcBef>
-              <a:spcAft>
-                <a:spcPts val="500"/>
+                <a:spcPts val="100"/>
+              </a:spcBef>
+              <a:spcAft>
+                <a:spcPts val="400"/>
               </a:spcAft>
             </a:pPr>
             <a:r>
@@ -8926,10 +10927,10 @@
           <a:p>
             <a:pPr>
               <a:spcBef>
-                <a:spcPts val="200"/>
-              </a:spcBef>
-              <a:spcAft>
-                <a:spcPts val="500"/>
+                <a:spcPts val="100"/>
+              </a:spcBef>
+              <a:spcAft>
+                <a:spcPts val="400"/>
               </a:spcAft>
             </a:pPr>
             <a:r>
@@ -8945,10 +10946,10 @@
           <a:p>
             <a:pPr>
               <a:spcBef>
-                <a:spcPts val="200"/>
-              </a:spcBef>
-              <a:spcAft>
-                <a:spcPts val="500"/>
+                <a:spcPts val="100"/>
+              </a:spcBef>
+              <a:spcAft>
+                <a:spcPts val="400"/>
               </a:spcAft>
             </a:pPr>
             <a:r>
@@ -8964,10 +10965,10 @@
           <a:p>
             <a:pPr lvl="1">
               <a:spcBef>
-                <a:spcPts val="200"/>
-              </a:spcBef>
-              <a:spcAft>
-                <a:spcPts val="500"/>
+                <a:spcPts val="100"/>
+              </a:spcBef>
+              <a:spcAft>
+                <a:spcPts val="400"/>
               </a:spcAft>
             </a:pPr>
             <a:r>
@@ -8983,10 +10984,10 @@
           <a:p>
             <a:pPr lvl="1">
               <a:spcBef>
-                <a:spcPts val="200"/>
-              </a:spcBef>
-              <a:spcAft>
-                <a:spcPts val="500"/>
+                <a:spcPts val="100"/>
+              </a:spcBef>
+              <a:spcAft>
+                <a:spcPts val="400"/>
               </a:spcAft>
             </a:pPr>
             <a:r>
@@ -9002,10 +11003,10 @@
           <a:p>
             <a:pPr lvl="1">
               <a:spcBef>
-                <a:spcPts val="200"/>
-              </a:spcBef>
-              <a:spcAft>
-                <a:spcPts val="500"/>
+                <a:spcPts val="100"/>
+              </a:spcBef>
+              <a:spcAft>
+                <a:spcPts val="400"/>
               </a:spcAft>
             </a:pPr>
             <a:r>
@@ -9021,10 +11022,10 @@
           <a:p>
             <a:pPr lvl="1">
               <a:spcBef>
-                <a:spcPts val="200"/>
-              </a:spcBef>
-              <a:spcAft>
-                <a:spcPts val="500"/>
+                <a:spcPts val="100"/>
+              </a:spcBef>
+              <a:spcAft>
+                <a:spcPts val="400"/>
               </a:spcAft>
             </a:pPr>
             <a:r>
@@ -9040,10 +11041,10 @@
           <a:p>
             <a:pPr lvl="1">
               <a:spcBef>
-                <a:spcPts val="200"/>
-              </a:spcBef>
-              <a:spcAft>
-                <a:spcPts val="500"/>
+                <a:spcPts val="100"/>
+              </a:spcBef>
+              <a:spcAft>
+                <a:spcPts val="400"/>
               </a:spcAft>
             </a:pPr>
             <a:r>
@@ -9059,10 +11060,10 @@
           <a:p>
             <a:pPr>
               <a:spcBef>
-                <a:spcPts val="200"/>
-              </a:spcBef>
-              <a:spcAft>
-                <a:spcPts val="500"/>
+                <a:spcPts val="100"/>
+              </a:spcBef>
+              <a:spcAft>
+                <a:spcPts val="400"/>
               </a:spcAft>
             </a:pPr>
             <a:r>
@@ -9078,10 +11079,10 @@
           <a:p>
             <a:pPr>
               <a:spcBef>
-                <a:spcPts val="200"/>
-              </a:spcBef>
-              <a:spcAft>
-                <a:spcPts val="500"/>
+                <a:spcPts val="100"/>
+              </a:spcBef>
+              <a:spcAft>
+                <a:spcPts val="400"/>
               </a:spcAft>
             </a:pPr>
             <a:r>
@@ -9097,10 +11098,10 @@
           <a:p>
             <a:pPr>
               <a:spcBef>
-                <a:spcPts val="200"/>
-              </a:spcBef>
-              <a:spcAft>
-                <a:spcPts val="500"/>
+                <a:spcPts val="100"/>
+              </a:spcBef>
+              <a:spcAft>
+                <a:spcPts val="400"/>
               </a:spcAft>
             </a:pPr>
             <a:r>
@@ -9123,8 +11124,8 @@
         </p:nvSpPr>
         <p:spPr>
           <a:xfrm>
-            <a:off x="594360" y="6263640"/>
-            <a:ext cx="10972800" cy="274320"/>
+            <a:off x="594360" y="6236208"/>
+            <a:ext cx="10972800" cy="228600"/>
           </a:xfrm>
           <a:prstGeom prst="rect">
             <a:avLst/>
@@ -9264,7 +11265,7 @@
         <p:spPr>
           <a:xfrm>
             <a:off x="502920" y="109728"/>
-            <a:ext cx="10789920" cy="365760"/>
+            <a:ext cx="10972800" cy="365760"/>
           </a:xfrm>
           <a:prstGeom prst="rect">
             <a:avLst/>
@@ -9298,7 +11299,7 @@
         <p:spPr>
           <a:xfrm>
             <a:off x="685800" y="1234440"/>
-            <a:ext cx="10972800" cy="4754880"/>
+            <a:ext cx="10972800" cy="4846320"/>
           </a:xfrm>
           <a:prstGeom prst="rect">
             <a:avLst/>
@@ -9313,14 +11314,14 @@
           <a:p>
             <a:pPr>
               <a:spcBef>
-                <a:spcPts val="200"/>
-              </a:spcBef>
-              <a:spcAft>
-                <a:spcPts val="500"/>
-              </a:spcAft>
-            </a:pPr>
-            <a:r>
-              <a:rPr sz="1800">
+                <a:spcPts val="100"/>
+              </a:spcBef>
+              <a:spcAft>
+                <a:spcPts val="400"/>
+              </a:spcAft>
+            </a:pPr>
+            <a:r>
+              <a:rPr sz="1600">
                 <a:solidFill>
                   <a:srgbClr val="0F172A"/>
                 </a:solidFill>
@@ -9332,14 +11333,14 @@
           <a:p>
             <a:pPr>
               <a:spcBef>
-                <a:spcPts val="200"/>
-              </a:spcBef>
-              <a:spcAft>
-                <a:spcPts val="500"/>
-              </a:spcAft>
-            </a:pPr>
-            <a:r>
-              <a:rPr sz="1800">
+                <a:spcPts val="100"/>
+              </a:spcBef>
+              <a:spcAft>
+                <a:spcPts val="400"/>
+              </a:spcAft>
+            </a:pPr>
+            <a:r>
+              <a:rPr sz="1600">
                 <a:solidFill>
                   <a:srgbClr val="0F172A"/>
                 </a:solidFill>
@@ -9351,14 +11352,14 @@
           <a:p>
             <a:pPr>
               <a:spcBef>
-                <a:spcPts val="200"/>
-              </a:spcBef>
-              <a:spcAft>
-                <a:spcPts val="500"/>
-              </a:spcAft>
-            </a:pPr>
-            <a:r>
-              <a:rPr sz="1800">
+                <a:spcPts val="100"/>
+              </a:spcBef>
+              <a:spcAft>
+                <a:spcPts val="400"/>
+              </a:spcAft>
+            </a:pPr>
+            <a:r>
+              <a:rPr sz="1600">
                 <a:solidFill>
                   <a:srgbClr val="0F172A"/>
                 </a:solidFill>
@@ -9370,14 +11371,14 @@
           <a:p>
             <a:pPr>
               <a:spcBef>
-                <a:spcPts val="200"/>
-              </a:spcBef>
-              <a:spcAft>
-                <a:spcPts val="500"/>
-              </a:spcAft>
-            </a:pPr>
-            <a:r>
-              <a:rPr sz="1800">
+                <a:spcPts val="100"/>
+              </a:spcBef>
+              <a:spcAft>
+                <a:spcPts val="400"/>
+              </a:spcAft>
+            </a:pPr>
+            <a:r>
+              <a:rPr sz="1600">
                 <a:solidFill>
                   <a:srgbClr val="0F172A"/>
                 </a:solidFill>
@@ -9389,14 +11390,14 @@
           <a:p>
             <a:pPr>
               <a:spcBef>
-                <a:spcPts val="200"/>
-              </a:spcBef>
-              <a:spcAft>
-                <a:spcPts val="500"/>
-              </a:spcAft>
-            </a:pPr>
-            <a:r>
-              <a:rPr sz="1800">
+                <a:spcPts val="100"/>
+              </a:spcBef>
+              <a:spcAft>
+                <a:spcPts val="400"/>
+              </a:spcAft>
+            </a:pPr>
+            <a:r>
+              <a:rPr sz="1600">
                 <a:solidFill>
                   <a:srgbClr val="0F172A"/>
                 </a:solidFill>
@@ -9408,14 +11409,14 @@
           <a:p>
             <a:pPr>
               <a:spcBef>
-                <a:spcPts val="200"/>
-              </a:spcBef>
-              <a:spcAft>
-                <a:spcPts val="500"/>
-              </a:spcAft>
-            </a:pPr>
-            <a:r>
-              <a:rPr sz="1800">
+                <a:spcPts val="100"/>
+              </a:spcBef>
+              <a:spcAft>
+                <a:spcPts val="400"/>
+              </a:spcAft>
+            </a:pPr>
+            <a:r>
+              <a:rPr sz="1600">
                 <a:solidFill>
                   <a:srgbClr val="0F172A"/>
                 </a:solidFill>
@@ -9427,14 +11428,14 @@
           <a:p>
             <a:pPr>
               <a:spcBef>
-                <a:spcPts val="200"/>
-              </a:spcBef>
-              <a:spcAft>
-                <a:spcPts val="500"/>
-              </a:spcAft>
-            </a:pPr>
-            <a:r>
-              <a:rPr sz="1800">
+                <a:spcPts val="100"/>
+              </a:spcBef>
+              <a:spcAft>
+                <a:spcPts val="400"/>
+              </a:spcAft>
+            </a:pPr>
+            <a:r>
+              <a:rPr sz="1600">
                 <a:solidFill>
                   <a:srgbClr val="0F172A"/>
                 </a:solidFill>
@@ -9446,14 +11447,14 @@
           <a:p>
             <a:pPr>
               <a:spcBef>
-                <a:spcPts val="200"/>
-              </a:spcBef>
-              <a:spcAft>
-                <a:spcPts val="500"/>
-              </a:spcAft>
-            </a:pPr>
-            <a:r>
-              <a:rPr sz="1800">
+                <a:spcPts val="100"/>
+              </a:spcBef>
+              <a:spcAft>
+                <a:spcPts val="400"/>
+              </a:spcAft>
+            </a:pPr>
+            <a:r>
+              <a:rPr sz="1600">
                 <a:solidFill>
                   <a:srgbClr val="0F172A"/>
                 </a:solidFill>
@@ -9465,14 +11466,14 @@
           <a:p>
             <a:pPr>
               <a:spcBef>
-                <a:spcPts val="200"/>
-              </a:spcBef>
-              <a:spcAft>
-                <a:spcPts val="500"/>
-              </a:spcAft>
-            </a:pPr>
-            <a:r>
-              <a:rPr sz="1800">
+                <a:spcPts val="100"/>
+              </a:spcBef>
+              <a:spcAft>
+                <a:spcPts val="400"/>
+              </a:spcAft>
+            </a:pPr>
+            <a:r>
+              <a:rPr sz="1600">
                 <a:solidFill>
                   <a:srgbClr val="0F172A"/>
                 </a:solidFill>
@@ -9484,14 +11485,14 @@
           <a:p>
             <a:pPr>
               <a:spcBef>
-                <a:spcPts val="200"/>
-              </a:spcBef>
-              <a:spcAft>
-                <a:spcPts val="500"/>
-              </a:spcAft>
-            </a:pPr>
-            <a:r>
-              <a:rPr sz="1800">
+                <a:spcPts val="100"/>
+              </a:spcBef>
+              <a:spcAft>
+                <a:spcPts val="400"/>
+              </a:spcAft>
+            </a:pPr>
+            <a:r>
+              <a:rPr sz="1600">
                 <a:solidFill>
                   <a:srgbClr val="0F172A"/>
                 </a:solidFill>
@@ -9503,14 +11504,14 @@
           <a:p>
             <a:pPr>
               <a:spcBef>
-                <a:spcPts val="200"/>
-              </a:spcBef>
-              <a:spcAft>
-                <a:spcPts val="500"/>
-              </a:spcAft>
-            </a:pPr>
-            <a:r>
-              <a:rPr sz="1800">
+                <a:spcPts val="100"/>
+              </a:spcBef>
+              <a:spcAft>
+                <a:spcPts val="400"/>
+              </a:spcAft>
+            </a:pPr>
+            <a:r>
+              <a:rPr sz="1600">
                 <a:solidFill>
                   <a:srgbClr val="0F172A"/>
                 </a:solidFill>
@@ -9522,14 +11523,14 @@
           <a:p>
             <a:pPr>
               <a:spcBef>
-                <a:spcPts val="200"/>
-              </a:spcBef>
-              <a:spcAft>
-                <a:spcPts val="500"/>
-              </a:spcAft>
-            </a:pPr>
-            <a:r>
-              <a:rPr sz="1800">
+                <a:spcPts val="100"/>
+              </a:spcBef>
+              <a:spcAft>
+                <a:spcPts val="400"/>
+              </a:spcAft>
+            </a:pPr>
+            <a:r>
+              <a:rPr sz="1600">
                 <a:solidFill>
                   <a:srgbClr val="0F172A"/>
                 </a:solidFill>
@@ -9541,14 +11542,14 @@
           <a:p>
             <a:pPr>
               <a:spcBef>
-                <a:spcPts val="200"/>
-              </a:spcBef>
-              <a:spcAft>
-                <a:spcPts val="500"/>
-              </a:spcAft>
-            </a:pPr>
-            <a:r>
-              <a:rPr sz="1800">
+                <a:spcPts val="100"/>
+              </a:spcBef>
+              <a:spcAft>
+                <a:spcPts val="400"/>
+              </a:spcAft>
+            </a:pPr>
+            <a:r>
+              <a:rPr sz="1600">
                 <a:solidFill>
                   <a:srgbClr val="0F172A"/>
                 </a:solidFill>
@@ -9560,14 +11561,14 @@
           <a:p>
             <a:pPr>
               <a:spcBef>
-                <a:spcPts val="200"/>
-              </a:spcBef>
-              <a:spcAft>
-                <a:spcPts val="500"/>
-              </a:spcAft>
-            </a:pPr>
-            <a:r>
-              <a:rPr sz="1800">
+                <a:spcPts val="100"/>
+              </a:spcBef>
+              <a:spcAft>
+                <a:spcPts val="400"/>
+              </a:spcAft>
+            </a:pPr>
+            <a:r>
+              <a:rPr sz="1600">
                 <a:solidFill>
                   <a:srgbClr val="0F172A"/>
                 </a:solidFill>
@@ -9579,14 +11580,14 @@
           <a:p>
             <a:pPr>
               <a:spcBef>
-                <a:spcPts val="200"/>
-              </a:spcBef>
-              <a:spcAft>
-                <a:spcPts val="500"/>
-              </a:spcAft>
-            </a:pPr>
-            <a:r>
-              <a:rPr sz="1800">
+                <a:spcPts val="100"/>
+              </a:spcBef>
+              <a:spcAft>
+                <a:spcPts val="400"/>
+              </a:spcAft>
+            </a:pPr>
+            <a:r>
+              <a:rPr sz="1600">
                 <a:solidFill>
                   <a:srgbClr val="0F172A"/>
                 </a:solidFill>
@@ -9605,8 +11606,8 @@
         </p:nvSpPr>
         <p:spPr>
           <a:xfrm>
-            <a:off x="594360" y="6263640"/>
-            <a:ext cx="10972800" cy="274320"/>
+            <a:off x="594360" y="6236208"/>
+            <a:ext cx="10972800" cy="228600"/>
           </a:xfrm>
           <a:prstGeom prst="rect">
             <a:avLst/>

</xml_diff>